<commit_message>
Arquitectura Clase 4: el codigo Mermaid C4 se proyecta junto al diagrama que dibuja
Co-Authored-By: Claude Opus 5.5 <noreply@anthropic.com>
</commit_message>
<xml_diff>
--- a/Arquitectura de Sistemas Computacionales/Clases/Clase 4 - Microservicios y arquitecturas distribuidas/Presentacion.pptx
+++ b/Arquitectura de Sistemas Computacionales/Clases/Clase 4 - Microservicios y arquitecturas distribuidas/Presentacion.pptx
@@ -654,49 +654,97 @@
           <a:p/>
           <a:p>
             <a:r>
-              <a:t>Un timeout es el tiempo maximo que un servicio espera respuesta antes de darse por vencido; sin timeout explicito, un servicio lento no falla sino que deja colgado a quien lo llamo, y el bloqueo se propaga hacia arriba hasta tumbar el sistema completo.</a:t>
+              <a:t>Si cada flecha del diagrama lleva protocolo y formato, el paso siguiente es decir QUE se negocia por esa flecha, y eso es un contrato.</a:t>
             </a:r>
           </a:p>
           <a:p/>
           <a:p>
             <a:r>
-              <a:t>Los valores tipicos para llamadas internas estan entre 2 y 5 segundos, y son convencion, no ley.</a:t>
+              <a:t>Un contrato entre dos piezas de un sistema tiene cuatro datos y los cuatro se piden por separado: como se llama la interaccion en terminos de negocio</a:t>
             </a:r>
           </a:p>
           <a:p/>
           <a:p>
             <a:r>
-              <a:t>Un reintento es volver a intentar la llamada fallida, y trae una trampa: si todos los clientes reintentan de inmediato contra un servicio ya saturado, lo hunden mas, por lo que se limita a dos o tres reintentos con espera creciente entre uno y otro.</a:t>
+              <a:t>Quien llama a quien, con que verbo y ruta —o con que nombre de evento, si es asincrono—, y cual es el error de negocio que puede devolver.</a:t>
             </a:r>
           </a:p>
           <a:p/>
           <a:p>
             <a:r>
-              <a:t>En CloudLite eso es literal: si el reintento de crear turno no es idempotente, el cliente termina con dos reservas para el mismo horario, y la solucion habitual es que la peticion lleve un identificador unico que el servidor reconozca como repetido.</a:t>
+              <a:t>El cuarto es el que se olvida y el que hace util al contrato.</a:t>
             </a:r>
           </a:p>
           <a:p/>
           <a:p>
             <a:r>
-              <a:t>El cuarto mecanismo es el interruptor de circuito, o circuit breaker, que tras varias fallas consecutivas deja de intentar por un rato y responde de inmediato con un error controlado, para no gastar recursos golpeando algo que esta caido.</a:t>
+              <a:t>Un error de negocio es una respuesta prevista, que forma parte del diseno: la franja ya esta tomada, el cupo se agoto, el usuario no tiene permiso.</a:t>
             </a:r>
           </a:p>
           <a:p/>
           <a:p>
             <a:r>
-              <a:t>NOTAS:</a:t>
+              <a:t>La primera: al menos uno de los tres contratos tiene que ser un 409 de conflicto, y la razon es de dominio y no de capricho.</a:t>
             </a:r>
           </a:p>
           <a:p/>
           <a:p>
             <a:r>
-              <a:t>De ahi salen cuatro mecanismos que el diagrama y la tabla deben poder mencionar.</a:t>
+              <a:t>El 409 es la respuesta que dice «tu peticion es valida, pero el estado actual del sistema no la admite», y en cualquier dominio de reservas ese caso existe siempre: dos clientes quieren la misma franja.</a:t>
             </a:r>
           </a:p>
           <a:p/>
           <a:p>
             <a:r>
-              <a:t>Los reintentos exigen idempotencia, que significa que ejecutar la misma operacion dos veces produzca el mismo resultado que ejecutarla una vez.</a:t>
+              <a:t>Un estudiante que no encuentra ningun 409 en su sistema casi nunca tiene un dominio sin conflictos; lo que tiene es un diagrama que no modela ninguna regla de negocio.</a:t>
+            </a:r>
+          </a:p>
+          <a:p/>
+          <a:p>
+            <a:r>
+              <a:t>La segunda exigencia: los tres contratos no pueden ser entre el mismo par de cajas.</a:t>
+            </a:r>
+          </a:p>
+          <a:p/>
+          <a:p>
+            <a:r>
+              <a:t>Y si el contrato es con la base de datos, en la columna del verbo va la sentencia (INSERT, SELECT) y no una ruta REST</a:t>
+            </a:r>
+          </a:p>
+          <a:p/>
+          <a:p>
+            <a:r>
+              <a:t>Porque la base no expone rutas; ponerle POST /turnos a la base de datos es el error que delata que se lleno la tabla por analogia y no leyendo el propio diagrama.</a:t>
+            </a:r>
+          </a:p>
+          <a:p/>
+          <a:p>
+            <a:r>
+              <a:t>(No se proyecta) Un 500 no es un error de negocio, es una falla del sistema; nadie lo disena, y por eso poner 500 en esa columna es la senal de que el estudiante no distinguio las dos cosas.</a:t>
+            </a:r>
+          </a:p>
+          <a:p/>
+          <a:p>
+            <a:r>
+              <a:t>(No se proyecta) La diapositiva proyecta los tres contratos resueltos sobre CloudLite Turnos y conviene recorrerlos leyendo la cuarta columna en voz alta, porque es lo que hay que replicar.</a:t>
+            </a:r>
+          </a:p>
+          <a:p/>
+          <a:p>
+            <a:r>
+              <a:t>(No se proyecta) Dos exigencias mas, que valen puntos y se pierden sin darse cuenta.</a:t>
+            </a:r>
+          </a:p>
+          <a:p/>
+          <a:p>
+            <a:r>
+              <a:t>(No se proyecta) Conviene tambien tener a mano la diferencia con sus vecinos, porque se confunden: 400 es que la peticion esta mal formada, 401 que no se sabe quien eres, 403 que se sabe y no te corresponde, 404 que no existe, 422 que esta bien formada pero sus datos no pasan una validacion, y 409 que choca con el estado actual.</a:t>
+            </a:r>
+          </a:p>
+          <a:p/>
+          <a:p>
+            <a:r>
+              <a:t>(No se proyecta) Tres filas que digan «App web → API» describen un solo canal contado tres veces, y lo que se esta evaluando es si el estudiante entendio que su sistema tiene varias fronteras.</a:t>
             </a:r>
           </a:p>
         </p:txBody>
@@ -772,73 +820,37 @@
           <a:p/>
           <a:p>
             <a:r>
-              <a:t>El punto donde los proyectos academicos se rompen es el de los datos.</a:t>
+              <a:t>El segundo bloque de contenido es el mas importante del dia: que se paga al distribuir.</a:t>
             </a:r>
           </a:p>
           <a:p/>
           <a:p>
             <a:r>
-              <a:t>La regla ortodoxa de los microservicios dice que cada servicio es dueno exclusivo de su base de datos y que nadie mas la consulta directamente</a:t>
+              <a:t>Una llamada a una funcion dentro del mismo proceso cuesta del orden de nanosegundos y no puede fallar por causas de red.</a:t>
             </a:r>
           </a:p>
           <a:p/>
           <a:p>
             <a:r>
-              <a:t>Si dos servicios comparten tablas, estan acoplados y no pueden desplegarse por separado, lo que contradice la definicion.</a:t>
+              <a:t>La misma llamada convertida en peticion HTTP entre dos contenedores de la misma maquina o del mismo centro de datos cuesta tipicamente entre 1 y 5 milisegundos, y entre regiones geograficas distintas puede subir a 50 o 200 milisegundos.</a:t>
             </a:r>
           </a:p>
           <a:p/>
           <a:p>
             <a:r>
-              <a:t>Pero cumplir esa regla tiene un precio real: una consulta que antes era un join deja de existir y hay que resolverla llamando a otro servicio</a:t>
+              <a:t>Es decir, convertir una llamada local en remota empeora el costo en varios ordenes de magnitud, y a eso se suma que ahora la llamada puede perderse, llegar duplicada o tardar indefinidamente.</a:t>
             </a:r>
           </a:p>
           <a:p/>
           <a:p>
             <a:r>
-              <a:t>Y una operacion que abarca dos servicios ya no puede ser una transaccion unica sino una secuencia de pasos con compensaciones.</a:t>
+              <a:t>Ese calculo es exacto y no una convencion, y es el argumento mas contundente contra multiplicar servicios sin necesidad.</a:t>
             </a:r>
           </a:p>
           <a:p/>
           <a:p>
             <a:r>
-              <a:t>Fingir ortodoxia es peor que documentar una concesion.</a:t>
-            </a:r>
-          </a:p>
-          <a:p/>
-          <a:p>
-            <a:r>
-              <a:t>La regla de propiedad es: cada tabla tiene un solo servicio dueno, que es el unico que escribe en ella; los demas la consultan por su API.</a:t>
-            </a:r>
-          </a:p>
-          <a:p/>
-          <a:p>
-            <a:r>
-              <a:t>En CloudLite Turnos la tabla de turnos es de la API de turnos, y el worker de avisos no la toca: recibe por la cola el dato que necesita.</a:t>
-            </a:r>
-          </a:p>
-          <a:p/>
-          <a:p>
-            <a:r>
-              <a:t>Dos servicios que escriben en la misma tabla quedan acoplados aunque se desplieguen por separado, y ese es el error mas comun.</a:t>
-            </a:r>
-          </a:p>
-          <a:p/>
-          <a:p>
-            <a:r>
-              <a:t>NOTAS:</a:t>
-            </a:r>
-          </a:p>
-          <a:p/>
-          <a:p>
-            <a:r>
-              <a:t>Eso introduce consistencia eventual, es decir un lapso durante el cual dos partes del sistema tienen versiones distintas de la verdad, con consecuencias visibles para el usuario.</a:t>
-            </a:r>
-          </a:p>
-          <a:p/>
-          <a:p>
-            <a:r>
-              <a:t>(No se proyecta) La postura honesta para este curso es que un CloudLite con una base de datos compartida y propiedad de tablas claramente documentada resulta aceptable, siempre que el estudiante lo registre como un trade-off consciente en su informe y no lo presente como microservicios puros.</a:t>
+              <a:t>(No se proyecta) Hay una aritmetica que conviene mostrar porque impresiona con razon: si una peticion del usuario atraviesa en cadena cinco servicios y cada uno esta disponible el 99,9 % del tiempo, la disponibilidad del recorrido completo es 0,999 elevado a la quinta potencia, alrededor del 99,5 %, lo que pasa de unos 43 minutos de indisponibilidad al mes a mas de tres horas.</a:t>
             </a:r>
           </a:p>
         </p:txBody>
@@ -914,157 +926,49 @@
           <a:p/>
           <a:p>
             <a:r>
-              <a:t>Los riesgos de distribucion no son una lista libre: son TRES riesgos, cada uno responde una pregunta distinta, y estan elegidos para que ninguno se pueda contestar sin mirar el propio diagrama.</a:t>
+              <a:t>Un timeout es el tiempo maximo que un servicio espera respuesta antes de darse por vencido; sin timeout explicito, un servicio lento no falla sino que deja colgado a quien lo llamo, y el bloqueo se propaga hacia arriba hasta tumbar el sistema completo.</a:t>
             </a:r>
           </a:p>
           <a:p/>
           <a:p>
             <a:r>
-              <a:t>Se nombra UNA caja del diagrama y se dice que deja de funcionar y —esta es la mitad que se olvida— que SIGUE funcionando.</a:t>
+              <a:t>Los valores tipicos para llamadas internas estan entre 2 y 5 segundos, y son convencion, no ley.</a:t>
             </a:r>
           </a:p>
           <a:p/>
           <a:p>
             <a:r>
-              <a:t>En CloudLite Turnos, si se cae el trabajador de notificaciones, los turnos se siguen reservando y lo que se pierde es el correo de confirmacion; si se cae la base de turnos, no se reserva nada</a:t>
+              <a:t>Un reintento es volver a intentar la llamada fallida, y trae una trampa: si todos los clientes reintentan de inmediato contra un servicio ya saturado, lo hunden mas, por lo que se limita a dos o tres reintentos con espera creciente entre uno y otro.</a:t>
             </a:r>
           </a:p>
           <a:p/>
           <a:p>
             <a:r>
-              <a:t>Pero la aplicacion web sigue cargando y puede mostrar un mensaje decente en lugar de una pantalla en blanco.</a:t>
+              <a:t>En CloudLite eso es literal: si el reintento de crear turno no es idempotente, el cliente termina con dos reservas para el mismo horario, y la solucion habitual es que la peticion lleve un identificador unico que el servidor reconozca como repetido.</a:t>
             </a:r>
           </a:p>
           <a:p/>
           <a:p>
             <a:r>
-              <a:t>Reservar un turno en el ejemplo de tres cajas son tres saltos: el navegador a la aplicacion web, la aplicacion web a la API, y la API a la base de datos; si se agrega el correo son cuatro, y si el correo se envia por cola, cinco.</a:t>
+              <a:t>El cuarto mecanismo es el interruptor de circuito, o circuit breaker, que tras varias fallas consecutivas deja de intentar por un rato y responde de inmediato con un error controlado, para no gastar recursos golpeando algo que esta caido.</a:t>
             </a:r>
           </a:p>
           <a:p/>
           <a:p>
             <a:r>
-              <a:t>El numero importa por lo que se explico arriba: cada salto agrega latencia y una probabilidad de fallo, y esa aritmetica es la unica defensa contra multiplicar cajas por gusto.</a:t>
+              <a:t>NOTAS:</a:t>
             </a:r>
           </a:p>
           <a:p/>
           <a:p>
             <a:r>
-              <a:t>Un estudiante que no puede contar sus saltos no esta leyendo su diagrama, esta recordandolo.</a:t>
+              <a:t>De ahi salen cuatro mecanismos que el diagrama y la tabla deben poder mencionar.</a:t>
             </a:r>
           </a:p>
           <a:p/>
           <a:p>
             <a:r>
-              <a:t>El tercero pregunta por un dato que se escribe en dos pasos, y es el mas dificil de los tres porque exige mirar la escritura y no la lectura.</a:t>
-            </a:r>
-          </a:p>
-          <a:p/>
-          <a:p>
-            <a:r>
-              <a:t>En el ejemplo, el turno se escribe en la base y despues se publica el mensaje del correo: si el segundo paso falla, el turno existe y el cliente nunca se entero.</a:t>
-            </a:r>
-          </a:p>
-          <a:p/>
-          <a:p>
-            <a:r>
-              <a:t>Ese es el problema de fondo de todo sistema distribuido, y hoy no se resuelve con una saga completa: se reconoce, se nombra el dato concreto y se dice que queda inconsistente.</a:t>
-            </a:r>
-          </a:p>
-          <a:p/>
-          <a:p>
-            <a:r>
-              <a:t>Si un estudiante dice que no encuentra ningun riesgo, casi siempre es porque su diagrama tiene flechas sin protocolo o sin formato: no sabe por donde puede romperse porque nunca definio como se comunican las piezas.</a:t>
-            </a:r>
-          </a:p>
-          <a:p/>
-          <a:p>
-            <a:r>
-              <a:t>Los tres riesgos clasicos de un sistema distribuido son: la red falla o se demora, un servicio deja de responder mientras los demas siguen, y los datos quedan inconsistentes entre dos servicios.</a:t>
-            </a:r>
-          </a:p>
-          <a:p/>
-          <a:p>
-            <a:r>
-              <a:t>En la app de turnos, si el worker de avisos cae, los turnos se siguen reservando y los avisos esperan en la cola: el fallo queda contenido.</a:t>
-            </a:r>
-          </a:p>
-          <a:p/>
-          <a:p>
-            <a:r>
-              <a:t>NOTAS:</a:t>
-            </a:r>
-          </a:p>
-          <a:p/>
-          <a:p>
-            <a:r>
-              <a:t>El primero pregunta que se cae.</a:t>
-            </a:r>
-          </a:p>
-          <a:p/>
-          <a:p>
-            <a:r>
-              <a:t>El segundo pregunta cuantos saltos de red tiene una operacion de punta a punta, y se responde con un numero, contado sobre el propio dibujo.</a:t>
-            </a:r>
-          </a:p>
-          <a:p/>
-          <a:p>
-            <a:r>
-              <a:t>PREGUNTAS FRECUENTES Y CIERRE CONCEPTUAL ()</a:t>
-            </a:r>
-          </a:p>
-          <a:p/>
-          <a:p>
-            <a:r>
-              <a:t>Cuantos microservicios son los correctos: no hay numero correcto, hay justificacion por frontera</a:t>
-            </a:r>
-          </a:p>
-          <a:p/>
-          <a:p>
-            <a:r>
-              <a:t>Y el rango de dos a cinco contenedores que exige el curso es una restriccion pedagogica pensada para proyectos de una a tres personas en doce semanas, no un hallazgo de la ingenieria.</a:t>
-            </a:r>
-          </a:p>
-          <a:p/>
-          <a:p>
-            <a:r>
-              <a:t>Si las empresas grandes tienen cientos de servicios, por que nosotros solo tres: porque el numero de servicios que una organizacion puede sostener es funcion del numero de equipos autonomos y de la madurez de su automatizacion de despliegue y observabilidad</a:t>
-            </a:r>
-          </a:p>
-          <a:p/>
-          <a:p>
-            <a:r>
-              <a:t>Condiciones que un equipo de tres no tiene, y copiar la forma sin las condiciones produce lo que aqui se llama microservicios teatro.</a:t>
-            </a:r>
-          </a:p>
-          <a:p/>
-          <a:p>
-            <a:r>
-              <a:t>Y la tercera, que hay que responder sin ambiguedad: esta mal hacer un monolito.</a:t>
-            </a:r>
-          </a:p>
-          <a:p/>
-          <a:p>
-            <a:r>
-              <a:t>(No se proyecta) Conviene dictarlos asi, porque un estudiante que entiende por que son esos tres no escribe generalidades.</a:t>
-            </a:r>
-          </a:p>
-          <a:p/>
-          <a:p>
-            <a:r>
-              <a:t>(No se proyecta) «Se cae todo» vale la mitad de los puntos, y con razon: en un sistema bien partido nunca se cae todo, y el ejercicio consiste precisamente en descubrir que algunas cosas sobreviven.</a:t>
-            </a:r>
-          </a:p>
-          <a:p/>
-          <a:p>
-            <a:r>
-              <a:t>(No se proyecta) Ese razonamiento es el que en la Clase 7 permite decidir que va en cada zona de red y en la Clase 13 que pieza vale la pena replicar.</a:t>
-            </a:r>
-          </a:p>
-          <a:p/>
-          <a:p>
-            <a:r>
-              <a:t>(No se proyecta) Devolverle el diagrama es mas util que darle un ejemplo.</a:t>
+              <a:t>Los reintentos exigen idempotencia, que significa que ejecutar la misma operacion dos veces produzca el mismo resultado que ejecutarla una vez.</a:t>
             </a:r>
           </a:p>
         </p:txBody>
@@ -1134,6 +1038,374 @@
           <a:lstStyle/>
           <a:p>
             <a:r>
+              <a:t>DESARROLLO (para explicarlo, no se proyecta):</a:t>
+            </a:r>
+          </a:p>
+          <a:p/>
+          <a:p>
+            <a:r>
+              <a:t>El punto donde los proyectos academicos se rompen es el de los datos.</a:t>
+            </a:r>
+          </a:p>
+          <a:p/>
+          <a:p>
+            <a:r>
+              <a:t>La regla ortodoxa de los microservicios dice que cada servicio es dueno exclusivo de su base de datos y que nadie mas la consulta directamente</a:t>
+            </a:r>
+          </a:p>
+          <a:p/>
+          <a:p>
+            <a:r>
+              <a:t>Si dos servicios comparten tablas, estan acoplados y no pueden desplegarse por separado, lo que contradice la definicion.</a:t>
+            </a:r>
+          </a:p>
+          <a:p/>
+          <a:p>
+            <a:r>
+              <a:t>Pero cumplir esa regla tiene un precio real: una consulta que antes era un join deja de existir y hay que resolverla llamando a otro servicio</a:t>
+            </a:r>
+          </a:p>
+          <a:p/>
+          <a:p>
+            <a:r>
+              <a:t>Y una operacion que abarca dos servicios ya no puede ser una transaccion unica sino una secuencia de pasos con compensaciones.</a:t>
+            </a:r>
+          </a:p>
+          <a:p/>
+          <a:p>
+            <a:r>
+              <a:t>Fingir ortodoxia es peor que documentar una concesion.</a:t>
+            </a:r>
+          </a:p>
+          <a:p/>
+          <a:p>
+            <a:r>
+              <a:t>La regla de propiedad es: cada tabla tiene un solo servicio dueno, que es el unico que escribe en ella; los demas la consultan por su API.</a:t>
+            </a:r>
+          </a:p>
+          <a:p/>
+          <a:p>
+            <a:r>
+              <a:t>En CloudLite Turnos la tabla de turnos es de la API de turnos, y el worker de avisos no la toca: recibe por la cola el dato que necesita.</a:t>
+            </a:r>
+          </a:p>
+          <a:p/>
+          <a:p>
+            <a:r>
+              <a:t>Dos servicios que escriben en la misma tabla quedan acoplados aunque se desplieguen por separado, y ese es el error mas comun.</a:t>
+            </a:r>
+          </a:p>
+          <a:p/>
+          <a:p>
+            <a:r>
+              <a:t>NOTAS:</a:t>
+            </a:r>
+          </a:p>
+          <a:p/>
+          <a:p>
+            <a:r>
+              <a:t>Eso introduce consistencia eventual, es decir un lapso durante el cual dos partes del sistema tienen versiones distintas de la verdad, con consecuencias visibles para el usuario.</a:t>
+            </a:r>
+          </a:p>
+          <a:p/>
+          <a:p>
+            <a:r>
+              <a:t>(No se proyecta) La postura honesta para este curso es que un CloudLite con una base de datos compartida y propiedad de tablas claramente documentada resulta aceptable, siempre que el estudiante lo registre como un trade-off consciente en su informe y no lo presente como microservicios puros.</a:t>
+            </a:r>
+          </a:p>
+        </p:txBody>
+      </p:sp>
+      <p:sp>
+        <p:nvSpPr>
+          <p:cNvPr id="4" name="Slide Number Placeholder 3"/>
+          <p:cNvSpPr>
+            <a:spLocks noGrp="1"/>
+          </p:cNvSpPr>
+          <p:nvPr>
+            <p:ph type="sldNum" idx="5" sz="quarter"/>
+          </p:nvPr>
+        </p:nvSpPr>
+        <p:spPr/>
+      </p:sp>
+    </p:spTree>
+  </p:cSld>
+  <p:clrMapOvr>
+    <a:masterClrMapping/>
+  </p:clrMapOvr>
+</p:notes>
+</file>
+
+<file path=ppt/notesSlides/notesSlide14.xml><?xml version="1.0" encoding="utf-8"?>
+<p:notes xmlns:a="http://schemas.openxmlformats.org/drawingml/2006/main" xmlns:p="http://schemas.openxmlformats.org/presentationml/2006/main" xmlns:r="http://schemas.openxmlformats.org/officeDocument/2006/relationships">
+  <p:cSld>
+    <p:spTree>
+      <p:nvGrpSpPr>
+        <p:cNvPr id="1" name=""/>
+        <p:cNvGrpSpPr/>
+        <p:nvPr/>
+      </p:nvGrpSpPr>
+      <p:grpSpPr>
+        <a:xfrm>
+          <a:off x="0" y="0"/>
+          <a:ext cx="0" cy="0"/>
+          <a:chOff x="0" y="0"/>
+          <a:chExt cx="0" cy="0"/>
+        </a:xfrm>
+      </p:grpSpPr>
+      <p:sp>
+        <p:nvSpPr>
+          <p:cNvPr id="2" name="Slide Image Placeholder 1"/>
+          <p:cNvSpPr>
+            <a:spLocks noGrp="1"/>
+          </p:cNvSpPr>
+          <p:nvPr>
+            <p:ph type="sldImg" idx="2"/>
+          </p:nvPr>
+        </p:nvSpPr>
+        <p:spPr/>
+      </p:sp>
+      <p:sp>
+        <p:nvSpPr>
+          <p:cNvPr id="3" name="Notes Placeholder 2"/>
+          <p:cNvSpPr>
+            <a:spLocks noGrp="1"/>
+          </p:cNvSpPr>
+          <p:nvPr>
+            <p:ph type="body" idx="3" sz="quarter"/>
+          </p:nvPr>
+        </p:nvSpPr>
+        <p:spPr/>
+        <p:txBody>
+          <a:bodyPr/>
+          <a:lstStyle/>
+          <a:p>
+            <a:r>
+              <a:t>DESARROLLO (para explicarlo, no se proyecta):</a:t>
+            </a:r>
+          </a:p>
+          <a:p/>
+          <a:p>
+            <a:r>
+              <a:t>Los riesgos de distribucion no son una lista libre: son TRES riesgos, cada uno responde una pregunta distinta, y estan elegidos para que ninguno se pueda contestar sin mirar el propio diagrama.</a:t>
+            </a:r>
+          </a:p>
+          <a:p/>
+          <a:p>
+            <a:r>
+              <a:t>Se nombra UNA caja del diagrama y se dice que deja de funcionar y —esta es la mitad que se olvida— que SIGUE funcionando.</a:t>
+            </a:r>
+          </a:p>
+          <a:p/>
+          <a:p>
+            <a:r>
+              <a:t>En CloudLite Turnos, si se cae el trabajador de notificaciones, los turnos se siguen reservando y lo que se pierde es el correo de confirmacion; si se cae la base de turnos, no se reserva nada</a:t>
+            </a:r>
+          </a:p>
+          <a:p/>
+          <a:p>
+            <a:r>
+              <a:t>Pero la aplicacion web sigue cargando y puede mostrar un mensaje decente en lugar de una pantalla en blanco.</a:t>
+            </a:r>
+          </a:p>
+          <a:p/>
+          <a:p>
+            <a:r>
+              <a:t>Reservar un turno en el ejemplo de tres cajas son tres saltos: el navegador a la aplicacion web, la aplicacion web a la API, y la API a la base de datos; si se agrega el correo son cuatro, y si el correo se envia por cola, cinco.</a:t>
+            </a:r>
+          </a:p>
+          <a:p/>
+          <a:p>
+            <a:r>
+              <a:t>El numero importa por lo que se explico arriba: cada salto agrega latencia y una probabilidad de fallo, y esa aritmetica es la unica defensa contra multiplicar cajas por gusto.</a:t>
+            </a:r>
+          </a:p>
+          <a:p/>
+          <a:p>
+            <a:r>
+              <a:t>Un estudiante que no puede contar sus saltos no esta leyendo su diagrama, esta recordandolo.</a:t>
+            </a:r>
+          </a:p>
+          <a:p/>
+          <a:p>
+            <a:r>
+              <a:t>El tercero pregunta por un dato que se escribe en dos pasos, y es el mas dificil de los tres porque exige mirar la escritura y no la lectura.</a:t>
+            </a:r>
+          </a:p>
+          <a:p/>
+          <a:p>
+            <a:r>
+              <a:t>En el ejemplo, el turno se escribe en la base y despues se publica el mensaje del correo: si el segundo paso falla, el turno existe y el cliente nunca se entero.</a:t>
+            </a:r>
+          </a:p>
+          <a:p/>
+          <a:p>
+            <a:r>
+              <a:t>Ese es el problema de fondo de todo sistema distribuido, y hoy no se resuelve con una saga completa: se reconoce, se nombra el dato concreto y se dice que queda inconsistente.</a:t>
+            </a:r>
+          </a:p>
+          <a:p/>
+          <a:p>
+            <a:r>
+              <a:t>Si un estudiante dice que no encuentra ningun riesgo, casi siempre es porque su diagrama tiene flechas sin protocolo o sin formato: no sabe por donde puede romperse porque nunca definio como se comunican las piezas.</a:t>
+            </a:r>
+          </a:p>
+          <a:p/>
+          <a:p>
+            <a:r>
+              <a:t>Los tres riesgos clasicos de un sistema distribuido son: la red falla o se demora, un servicio deja de responder mientras los demas siguen, y los datos quedan inconsistentes entre dos servicios.</a:t>
+            </a:r>
+          </a:p>
+          <a:p/>
+          <a:p>
+            <a:r>
+              <a:t>En la app de turnos, si el worker de avisos cae, los turnos se siguen reservando y los avisos esperan en la cola: el fallo queda contenido.</a:t>
+            </a:r>
+          </a:p>
+          <a:p/>
+          <a:p>
+            <a:r>
+              <a:t>NOTAS:</a:t>
+            </a:r>
+          </a:p>
+          <a:p/>
+          <a:p>
+            <a:r>
+              <a:t>El primero pregunta que se cae.</a:t>
+            </a:r>
+          </a:p>
+          <a:p/>
+          <a:p>
+            <a:r>
+              <a:t>El segundo pregunta cuantos saltos de red tiene una operacion de punta a punta, y se responde con un numero, contado sobre el propio dibujo.</a:t>
+            </a:r>
+          </a:p>
+          <a:p/>
+          <a:p>
+            <a:r>
+              <a:t>PREGUNTAS FRECUENTES Y CIERRE CONCEPTUAL ()</a:t>
+            </a:r>
+          </a:p>
+          <a:p/>
+          <a:p>
+            <a:r>
+              <a:t>Cuantos microservicios son los correctos: no hay numero correcto, hay justificacion por frontera</a:t>
+            </a:r>
+          </a:p>
+          <a:p/>
+          <a:p>
+            <a:r>
+              <a:t>Y el rango de dos a cinco contenedores que exige el curso es una restriccion pedagogica pensada para proyectos de una a tres personas en doce semanas, no un hallazgo de la ingenieria.</a:t>
+            </a:r>
+          </a:p>
+          <a:p/>
+          <a:p>
+            <a:r>
+              <a:t>Si las empresas grandes tienen cientos de servicios, por que nosotros solo tres: porque el numero de servicios que una organizacion puede sostener es funcion del numero de equipos autonomos y de la madurez de su automatizacion de despliegue y observabilidad</a:t>
+            </a:r>
+          </a:p>
+          <a:p/>
+          <a:p>
+            <a:r>
+              <a:t>Condiciones que un equipo de tres no tiene, y copiar la forma sin las condiciones produce lo que aqui se llama microservicios teatro.</a:t>
+            </a:r>
+          </a:p>
+          <a:p/>
+          <a:p>
+            <a:r>
+              <a:t>Y la tercera, que hay que responder sin ambiguedad: esta mal hacer un monolito.</a:t>
+            </a:r>
+          </a:p>
+          <a:p/>
+          <a:p>
+            <a:r>
+              <a:t>(No se proyecta) Conviene dictarlos asi, porque un estudiante que entiende por que son esos tres no escribe generalidades.</a:t>
+            </a:r>
+          </a:p>
+          <a:p/>
+          <a:p>
+            <a:r>
+              <a:t>(No se proyecta) «Se cae todo» vale la mitad de los puntos, y con razon: en un sistema bien partido nunca se cae todo, y el ejercicio consiste precisamente en descubrir que algunas cosas sobreviven.</a:t>
+            </a:r>
+          </a:p>
+          <a:p/>
+          <a:p>
+            <a:r>
+              <a:t>(No se proyecta) Ese razonamiento es el que en la Clase 7 permite decidir que va en cada zona de red y en la Clase 13 que pieza vale la pena replicar.</a:t>
+            </a:r>
+          </a:p>
+          <a:p/>
+          <a:p>
+            <a:r>
+              <a:t>(No se proyecta) Devolverle el diagrama es mas util que darle un ejemplo.</a:t>
+            </a:r>
+          </a:p>
+        </p:txBody>
+      </p:sp>
+      <p:sp>
+        <p:nvSpPr>
+          <p:cNvPr id="4" name="Slide Number Placeholder 3"/>
+          <p:cNvSpPr>
+            <a:spLocks noGrp="1"/>
+          </p:cNvSpPr>
+          <p:nvPr>
+            <p:ph type="sldNum" idx="5" sz="quarter"/>
+          </p:nvPr>
+        </p:nvSpPr>
+        <p:spPr/>
+      </p:sp>
+    </p:spTree>
+  </p:cSld>
+  <p:clrMapOvr>
+    <a:masterClrMapping/>
+  </p:clrMapOvr>
+</p:notes>
+</file>
+
+<file path=ppt/notesSlides/notesSlide15.xml><?xml version="1.0" encoding="utf-8"?>
+<p:notes xmlns:a="http://schemas.openxmlformats.org/drawingml/2006/main" xmlns:p="http://schemas.openxmlformats.org/presentationml/2006/main" xmlns:r="http://schemas.openxmlformats.org/officeDocument/2006/relationships">
+  <p:cSld>
+    <p:spTree>
+      <p:nvGrpSpPr>
+        <p:cNvPr id="1" name=""/>
+        <p:cNvGrpSpPr/>
+        <p:nvPr/>
+      </p:nvGrpSpPr>
+      <p:grpSpPr>
+        <a:xfrm>
+          <a:off x="0" y="0"/>
+          <a:ext cx="0" cy="0"/>
+          <a:chOff x="0" y="0"/>
+          <a:chExt cx="0" cy="0"/>
+        </a:xfrm>
+      </p:grpSpPr>
+      <p:sp>
+        <p:nvSpPr>
+          <p:cNvPr id="2" name="Slide Image Placeholder 1"/>
+          <p:cNvSpPr>
+            <a:spLocks noGrp="1"/>
+          </p:cNvSpPr>
+          <p:nvPr>
+            <p:ph type="sldImg" idx="2"/>
+          </p:nvPr>
+        </p:nvSpPr>
+        <p:spPr/>
+      </p:sp>
+      <p:sp>
+        <p:nvSpPr>
+          <p:cNvPr id="3" name="Notes Placeholder 2"/>
+          <p:cNvSpPr>
+            <a:spLocks noGrp="1"/>
+          </p:cNvSpPr>
+          <p:nvPr>
+            <p:ph type="body" idx="3" sz="quarter"/>
+          </p:nvPr>
+        </p:nvSpPr>
+        <p:spPr/>
+        <p:txBody>
+          <a:bodyPr/>
+          <a:lstStyle/>
+          <a:p>
+            <a:r>
               <a:t>TEXTO COMPLETO DE LA LÁMINA (se proyecta resumido):</a:t>
             </a:r>
           </a:p>
@@ -1744,43 +2016,62 @@
           <a:lstStyle/>
           <a:p>
             <a:r>
-              <a:t>TEXTO COMPLETO DE LA LÁMINA (se proyecta resumido):</a:t>
+              <a:t>QUÉ ES (dilo así): En Mermaid un diagrama C4 se escribe como texto. A la izquierda está ese texto; a la derecha, lo que dibuja. El visor dibuja cualquier cosa que tenga la sintaxis correcta, pero hay tres reglas que no revisa por ti.</a:t>
             </a:r>
           </a:p>
           <a:p/>
           <a:p>
             <a:r>
-              <a:t>Se abre la ÚNICA caja del Context de la Clase 1: los actores y los externos siguen ahí, fuera del sistema.</a:t>
+              <a:t>CÓMO DARLA (≈3 min):</a:t>
+            </a:r>
+          </a:p>
+          <a:p>
+            <a:r>
+              <a:t>  • Al entrar: Lee el código línea por línea señalando su caja en el dibujo: Container → la caja de la API; ContainerDb → el cilindro; Rel → la flecha con su rótulo.</a:t>
+            </a:r>
+          </a:p>
+          <a:p>
+            <a:r>
+              <a:t>  • Clic 1: Regla 1: el tercer dato del Container es la tecnología (Node.js). Sin ella, el diagrama no dice con qué se construye.</a:t>
+            </a:r>
+          </a:p>
+          <a:p>
+            <a:r>
+              <a:t>  • Clic 2: Regla 2: lo que guarda datos se declara ContainerDb, por eso sale como cilindro y no como una caja más.</a:t>
+            </a:r>
+          </a:p>
+          <a:p>
+            <a:r>
+              <a:t>  • Clic 3: Regla 3: cada Rel lleva verbo («INSERT y SELECT») y protocolo/formato («TCP/SQL»). «usa» no le dice nada a quien lee.</a:t>
             </a:r>
           </a:p>
           <a:p/>
           <a:p>
             <a:r>
-              <a:t>Tres datos por caja, obligatorios: nombre · tecnología · responsabilidad en una frase.</a:t>
+              <a:t>EJEMPLO: Mal: Container(api, "API") — sin tecnología. Rel(api, db, "usa") — sin verbo concreto ni protocolo.</a:t>
             </a:r>
           </a:p>
           <a:p/>
           <a:p>
             <a:r>
-              <a:t>Lo que guarda datos se marca como almacén (`ContainerDb`), no como una caja más.</a:t>
+              <a:t>SI PREGUNTAN:</a:t>
+            </a:r>
+          </a:p>
+          <a:p>
+            <a:r>
+              <a:t>  • «¿Dónde pruebo el código?» → En cualquier visor de Mermaid (por ejemplo mermaid.live): se pega el texto y se ve el dibujo.</a:t>
             </a:r>
           </a:p>
           <a:p/>
           <a:p>
             <a:r>
-              <a:t>Los nombres son idénticos a los del C4 Context: si allí decía «Pasarela de pagos», aquí no puede decir «Pagos».</a:t>
+              <a:t>CUIDADO: Los nombres (api, db) se repiten idénticos en el diagrama de Despliegue y en el de Componentes: si cambian, ya no se puede seguir una pieza entre diagramas.</a:t>
             </a:r>
           </a:p>
           <a:p/>
           <a:p>
             <a:r>
-              <a:t>Cada flecha lleva protocolo Y formato (`HTTPS/JSON`, `TCP/SQL`): una línea muda no cuenta.</a:t>
-            </a:r>
-          </a:p>
-          <a:p/>
-          <a:p>
-            <a:r>
-              <a:t>Entre 2 y 5 cajas. El número tiene que ser coherente con la decisión de la diapositiva anterior.</a:t>
+              <a:t>PASA A LA SIGUIENTE: Ahora el diagrama completo de la app de turnos con el mismo molde.</a:t>
             </a:r>
           </a:p>
         </p:txBody>
@@ -1850,85 +2141,43 @@
           <a:lstStyle/>
           <a:p>
             <a:r>
-              <a:t>DESARROLLO (para explicarlo, no se proyecta):</a:t>
+              <a:t>TEXTO COMPLETO DE LA LÁMINA (se proyecta resumido):</a:t>
             </a:r>
           </a:p>
           <a:p/>
           <a:p>
             <a:r>
-              <a:t>En este curso el diagrama se escribe como codigo Mermaid, y un visor Mermaid lo renderiza.</a:t>
+              <a:t>Se abre la ÚNICA caja del Context de la Clase 1: los actores y los externos siguen ahí, fuera del sistema.</a:t>
             </a:r>
           </a:p>
           <a:p/>
           <a:p>
             <a:r>
-              <a:t>La primera linea es exactamente C4Container, sin nada antes</a:t>
+              <a:t>Tres datos por caja, obligatorios: nombre · tecnología · responsabilidad en una frase.</a:t>
             </a:r>
           </a:p>
           <a:p/>
           <a:p>
             <a:r>
-              <a:t>Los actores se declaran con Person y los sistemas ajenos con System_Ext, los dos por fuera del bloque del sistema.</a:t>
+              <a:t>Lo que guarda datos se marca como almacén (`ContainerDb`), no como una caja más.</a:t>
             </a:r>
           </a:p>
           <a:p/>
           <a:p>
             <a:r>
-              <a:t>El sistema propio se abre con System_Boundary y una llave, y dentro van las cajas: Container para lo que ejecuta y ContainerDb para lo que almacena, cada una con identificador, nombre, tecnologia y responsabilidad.</a:t>
+              <a:t>Los nombres son idénticos a los del C4 Context: si allí decía «Pasarela de pagos», aquí no puede decir «Pagos».</a:t>
             </a:r>
           </a:p>
           <a:p/>
           <a:p>
             <a:r>
-              <a:t>La llave se cierra, y las relaciones van despues, con Rel y cuatro datos: origen, destino, que hace y con que protocolo y formato.</a:t>
+              <a:t>Cada flecha lleva protocolo Y formato (`HTTPS/JSON`, `TCP/SQL`): una línea muda no cuenta.</a:t>
             </a:r>
           </a:p>
           <a:p/>
           <a:p>
             <a:r>
-              <a:t>El identificador corto de cada caja —en el molde proyectado son spa, api, db y worker— es el que usan las relaciones; si no coincide, no dibuja la flecha y tampoco avisa con claridad.</a:t>
-            </a:r>
-          </a:p>
-          <a:p/>
-          <a:p>
-            <a:r>
-              <a:t>La regla operativa del dia se dice como consecuencia y no como consejo: se pega el codigo, se mira renderizado, y solo entonces se envia.</a:t>
-            </a:r>
-          </a:p>
-          <a:p/>
-          <a:p>
-            <a:r>
-              <a:t>(No se proyecta) Eso cambia lo que el docente tiene que ensenar, porque un boceto correcto escrito con la sintaxis equivocada no renderiza y entonces no hay diagrama que calificar.</a:t>
-            </a:r>
-          </a:p>
-          <a:p/>
-          <a:p>
-            <a:r>
-              <a:t>(No se proyecta) Son cinco reglas de escritura y conviene recorrerlas sobre la diapositiva, linea por linea.</a:t>
-            </a:r>
-          </a:p>
-          <a:p/>
-          <a:p>
-            <a:r>
-              <a:t>(No se proyecta) C4Context es el nivel de la Clase 1 y graph TD es otro tipo de diagrama, y cualquiera de los dos deja la respuesta en el nivel equivocado.</a:t>
-            </a:r>
-          </a:p>
-          <a:p/>
-          <a:p>
-            <a:r>
-              <a:t>(No se proyecta) Vale la pena decir en voz alta que aqui el uso de una IA es legitimo y ademas recomendado: pasar un boceto a codigo Mermaid es justo la tarea mecanica en la que ayuda sin sustituir el criterio.</a:t>
-            </a:r>
-          </a:p>
-          <a:p/>
-          <a:p>
-            <a:r>
-              <a:t>(No se proyecta) Lo que NO delega el estudiante es la revision, y hay tres cosas que tiene que verificar el mismo antes de enviar, porque son las que la IA equivoca con frecuencia: que la primera linea sea C4Container, que la base de datos haya quedado como ContainerDb y no como Container, y que ninguna relacion haya perdido la mitad de su etiqueta.</a:t>
-            </a:r>
-          </a:p>
-          <a:p/>
-          <a:p>
-            <a:r>
-              <a:t>(No se proyecta) Un codigo que no renderiza vale cero, y es el unico punto del taller donde el estudiante puede comprobar su propia nota antes de entregar.</a:t>
+              <a:t>Entre 2 y 5 cajas. El número tiene que ser coherente con la decisión de la diapositiva anterior.</a:t>
             </a:r>
           </a:p>
         </p:txBody>
@@ -2004,67 +2253,79 @@
           <a:p/>
           <a:p>
             <a:r>
-              <a:t>CloudLite Turnos, el sistema de agendamiento de la barberia, empieza con tres contenedores: una aplicacion web que corre en el navegador del cliente, una API que atiende peticiones HTTP con cuerpo en formato JSON</a:t>
+              <a:t>En este curso el diagrama se escribe como codigo Mermaid, y un visor Mermaid lo renderiza.</a:t>
             </a:r>
           </a:p>
           <a:p/>
           <a:p>
             <a:r>
-              <a:t>Y una base de datos relacional donde viven turnos, clientes y horarios.</a:t>
+              <a:t>La primera linea es exactamente C4Container, sin nada antes</a:t>
             </a:r>
           </a:p>
           <a:p/>
           <a:p>
             <a:r>
-              <a:t>Ahora viene la parte interesante: la cuarta caja aparece solo si hay una razon.</a:t>
+              <a:t>Los actores se declaran con Person y los sistemas ajenos con System_Ext, los dos por fuera del bloque del sistema.</a:t>
             </a:r>
           </a:p>
           <a:p/>
           <a:p>
             <a:r>
-              <a:t>El envio del correo de confirmacion tarda, con proveedores reales de correo, entre 300 y 2000 milisegundos, y puede fallar por causas ajenas al sistema.</a:t>
+              <a:t>El sistema propio se abre con System_Boundary y una llave, y dentro van las cajas: Container para lo que ejecuta y ContainerDb para lo que almacena, cada una con identificador, nombre, tecnologia y responsabilidad.</a:t>
             </a:r>
           </a:p>
           <a:p/>
           <a:p>
             <a:r>
-              <a:t>Cuatro contenedores con una justificacion medible es mejor arquitectura que ocho por moda.</a:t>
+              <a:t>La llave se cierra, y las relaciones van despues, con Rel y cuatro datos: origen, destino, que hace y con que protocolo y formato.</a:t>
             </a:r>
           </a:p>
           <a:p/>
           <a:p>
             <a:r>
-              <a:t>NOTAS:</a:t>
+              <a:t>El identificador corto de cada caja —en el molde proyectado son spa, api, db y worker— es el que usan las relaciones; si no coincide, no dibuja la flecha y tampoco avisa con claridad.</a:t>
             </a:r>
           </a:p>
           <a:p/>
           <a:p>
             <a:r>
-              <a:t>La flecha entre la web y la API dice «HTTPS/JSON, consulta disponibilidad y crea reservas»; la flecha entre la API y la base de datos dice «TCP, lee y escribe turnos».</a:t>
+              <a:t>La regla operativa del dia se dice como consecuencia y no como consejo: se pega el codigo, se mira renderizado, y solo entonces se envia.</a:t>
             </a:r>
           </a:p>
           <a:p/>
           <a:p>
             <a:r>
-              <a:t>Con eso ya existe un diagrama valido y defendible.</a:t>
+              <a:t>(No se proyecta) Eso cambia lo que el docente tiene que ensenar, porque un boceto correcto escrito con la sintaxis equivocada no renderiza y entonces no hay diagrama que calificar.</a:t>
             </a:r>
           </a:p>
           <a:p/>
           <a:p>
             <a:r>
-              <a:t>Si la API espera ese envio antes de responder, la reserva de un turno hereda esa latencia y ese riesgo.</a:t>
+              <a:t>(No se proyecta) Son cinco reglas de escritura y conviene recorrerlas sobre la diapositiva, linea por linea.</a:t>
             </a:r>
           </a:p>
           <a:p/>
           <a:p>
             <a:r>
-              <a:t>Esa es una razon legitima para separar: se agrega una cola de mensajes y un trabajador de notificaciones, la API escribe el turno, publica un mensaje y responde en decenas de milisegundos, y el trabajador envia el correo despues, con reintentos si falla.</a:t>
+              <a:t>(No se proyecta) C4Context es el nivel de la Clase 1 y graph TD es otro tipo de diagrama, y cualquiera de los dos deja la respuesta en el nivel equivocado.</a:t>
             </a:r>
           </a:p>
           <a:p/>
           <a:p>
             <a:r>
-              <a:t>(No se proyecta) Primer ejemplo concreto, y conviene construirlo en el tablero en vivo.</a:t>
+              <a:t>(No se proyecta) Vale la pena decir en voz alta que aqui el uso de una IA es legitimo y ademas recomendado: pasar un boceto a codigo Mermaid es justo la tarea mecanica en la que ayuda sin sustituir el criterio.</a:t>
+            </a:r>
+          </a:p>
+          <a:p/>
+          <a:p>
+            <a:r>
+              <a:t>(No se proyecta) Lo que NO delega el estudiante es la revision, y hay tres cosas que tiene que verificar el mismo antes de enviar, porque son las que la IA equivoca con frecuencia: que la primera linea sea C4Container, que la base de datos haya quedado como ContainerDb y no como Container, y que ninguna relacion haya perdido la mitad de su etiqueta.</a:t>
+            </a:r>
+          </a:p>
+          <a:p/>
+          <a:p>
+            <a:r>
+              <a:t>(No se proyecta) Un codigo que no renderiza vale cero, y es el unico punto del taller donde el estudiante puede comprobar su propia nota antes de entregar.</a:t>
             </a:r>
           </a:p>
         </p:txBody>
@@ -2134,103 +2395,57 @@
           <a:lstStyle/>
           <a:p>
             <a:r>
-              <a:t>DESARROLLO (para explicarlo, no se proyecta):</a:t>
+              <a:t>QUÉ ES (dilo así): Es el diagrama de contenedores completo de una app de turnos: quién la usa, de qué piezas está hecha por dentro y con qué sistema externo habla.</a:t>
             </a:r>
           </a:p>
           <a:p/>
           <a:p>
             <a:r>
-              <a:t>Si cada flecha del diagrama lleva protocolo y formato, el paso siguiente es decir QUE se negocia por esa flecha, y eso es un contrato.</a:t>
+              <a:t>CÓMO DARLA (≈4 min):</a:t>
+            </a:r>
+          </a:p>
+          <a:p>
+            <a:r>
+              <a:t>  • Al entrar: Arriba del código y del dibujo: Person es el cliente, fuera del sistema. System_Boundary es el recuadro punteado: todo lo que va dentro es nuestro.</a:t>
+            </a:r>
+          </a:p>
+          <a:p>
+            <a:r>
+              <a:t>  • Clic 1: Dentro, los cuatro contenedores: app web (React), API (Node.js), base (PostgreSQL, cilindro) y worker de avisos. Fuera, el correo, en gris porque es un sistema externo.</a:t>
+            </a:r>
+          </a:p>
+          <a:p>
+            <a:r>
+              <a:t>  • Clic 2: Recorre las Rel en el orden de una reserva: el cliente reserva por HTTPS, la app hace POST a la API, la API escribe en la base y publica un evento, el worker envía el correo.</a:t>
             </a:r>
           </a:p>
           <a:p/>
           <a:p>
             <a:r>
-              <a:t>Un contrato entre dos piezas de un sistema tiene cuatro datos y los cuatro se piden por separado: como se llama la interaccion en terminos de negocio</a:t>
+              <a:t>EJEMPLO: Seguir una reserva de punta a punta sobre el dibujo es la mejor prueba de que el diagrama está completo.</a:t>
             </a:r>
           </a:p>
           <a:p/>
           <a:p>
             <a:r>
-              <a:t>Quien llama a quien, con que verbo y ruta —o con que nombre de evento, si es asincrono—, y cual es el error de negocio que puede devolver.</a:t>
+              <a:t>SI PREGUNTAN:</a:t>
+            </a:r>
+          </a:p>
+          <a:p>
+            <a:r>
+              <a:t>  • «¿Por qué el correo va fuera del recuadro?» → Porque no lo construimos ni lo operamos: es un servicio de terceros. Los externos siempre van fuera del System_Boundary.</a:t>
             </a:r>
           </a:p>
           <a:p/>
           <a:p>
             <a:r>
-              <a:t>El cuarto es el que se olvida y el que hace util al contrato.</a:t>
+              <a:t>CUIDADO: Si un contenedor no tiene ninguna flecha, sobra o falta una relación.</a:t>
             </a:r>
           </a:p>
           <a:p/>
           <a:p>
             <a:r>
-              <a:t>Un error de negocio es una respuesta prevista, que forma parte del diseno: la franja ya esta tomada, el cupo se agoto, el usuario no tiene permiso.</a:t>
-            </a:r>
-          </a:p>
-          <a:p/>
-          <a:p>
-            <a:r>
-              <a:t>La primera: al menos uno de los tres contratos tiene que ser un 409 de conflicto, y la razon es de dominio y no de capricho.</a:t>
-            </a:r>
-          </a:p>
-          <a:p/>
-          <a:p>
-            <a:r>
-              <a:t>El 409 es la respuesta que dice «tu peticion es valida, pero el estado actual del sistema no la admite», y en cualquier dominio de reservas ese caso existe siempre: dos clientes quieren la misma franja.</a:t>
-            </a:r>
-          </a:p>
-          <a:p/>
-          <a:p>
-            <a:r>
-              <a:t>Un estudiante que no encuentra ningun 409 en su sistema casi nunca tiene un dominio sin conflictos; lo que tiene es un diagrama que no modela ninguna regla de negocio.</a:t>
-            </a:r>
-          </a:p>
-          <a:p/>
-          <a:p>
-            <a:r>
-              <a:t>La segunda exigencia: los tres contratos no pueden ser entre el mismo par de cajas.</a:t>
-            </a:r>
-          </a:p>
-          <a:p/>
-          <a:p>
-            <a:r>
-              <a:t>Y si el contrato es con la base de datos, en la columna del verbo va la sentencia (INSERT, SELECT) y no una ruta REST</a:t>
-            </a:r>
-          </a:p>
-          <a:p/>
-          <a:p>
-            <a:r>
-              <a:t>Porque la base no expone rutas; ponerle POST /turnos a la base de datos es el error que delata que se lleno la tabla por analogia y no leyendo el propio diagrama.</a:t>
-            </a:r>
-          </a:p>
-          <a:p/>
-          <a:p>
-            <a:r>
-              <a:t>(No se proyecta) Un 500 no es un error de negocio, es una falla del sistema; nadie lo disena, y por eso poner 500 en esa columna es la senal de que el estudiante no distinguio las dos cosas.</a:t>
-            </a:r>
-          </a:p>
-          <a:p/>
-          <a:p>
-            <a:r>
-              <a:t>(No se proyecta) La diapositiva proyecta los tres contratos resueltos sobre CloudLite Turnos y conviene recorrerlos leyendo la cuarta columna en voz alta, porque es lo que hay que replicar.</a:t>
-            </a:r>
-          </a:p>
-          <a:p/>
-          <a:p>
-            <a:r>
-              <a:t>(No se proyecta) Dos exigencias mas, que valen puntos y se pierden sin darse cuenta.</a:t>
-            </a:r>
-          </a:p>
-          <a:p/>
-          <a:p>
-            <a:r>
-              <a:t>(No se proyecta) Conviene tambien tener a mano la diferencia con sus vecinos, porque se confunden: 400 es que la peticion esta mal formada, 401 que no se sabe quien eres, 403 que se sabe y no te corresponde, 404 que no existe, 422 que esta bien formada pero sus datos no pasan una validacion, y 409 que choca con el estado actual.</a:t>
-            </a:r>
-          </a:p>
-          <a:p/>
-          <a:p>
-            <a:r>
-              <a:t>(No se proyecta) Tres filas que digan «App web → API» describen un solo canal contado tres veces, y lo que se esta evaluando es si el estudiante entendio que su sistema tiene varias fronteras.</a:t>
+              <a:t>PASA A LA SIGUIENTE: Con este molde se arma el diagrama de cualquier sistema.</a:t>
             </a:r>
           </a:p>
         </p:txBody>
@@ -2306,37 +2521,67 @@
           <a:p/>
           <a:p>
             <a:r>
-              <a:t>El segundo bloque de contenido es el mas importante del dia: que se paga al distribuir.</a:t>
+              <a:t>CloudLite Turnos, el sistema de agendamiento de la barberia, empieza con tres contenedores: una aplicacion web que corre en el navegador del cliente, una API que atiende peticiones HTTP con cuerpo en formato JSON</a:t>
             </a:r>
           </a:p>
           <a:p/>
           <a:p>
             <a:r>
-              <a:t>Una llamada a una funcion dentro del mismo proceso cuesta del orden de nanosegundos y no puede fallar por causas de red.</a:t>
+              <a:t>Y una base de datos relacional donde viven turnos, clientes y horarios.</a:t>
             </a:r>
           </a:p>
           <a:p/>
           <a:p>
             <a:r>
-              <a:t>La misma llamada convertida en peticion HTTP entre dos contenedores de la misma maquina o del mismo centro de datos cuesta tipicamente entre 1 y 5 milisegundos, y entre regiones geograficas distintas puede subir a 50 o 200 milisegundos.</a:t>
+              <a:t>Ahora viene la parte interesante: la cuarta caja aparece solo si hay una razon.</a:t>
             </a:r>
           </a:p>
           <a:p/>
           <a:p>
             <a:r>
-              <a:t>Es decir, convertir una llamada local en remota empeora el costo en varios ordenes de magnitud, y a eso se suma que ahora la llamada puede perderse, llegar duplicada o tardar indefinidamente.</a:t>
+              <a:t>El envio del correo de confirmacion tarda, con proveedores reales de correo, entre 300 y 2000 milisegundos, y puede fallar por causas ajenas al sistema.</a:t>
             </a:r>
           </a:p>
           <a:p/>
           <a:p>
             <a:r>
-              <a:t>Ese calculo es exacto y no una convencion, y es el argumento mas contundente contra multiplicar servicios sin necesidad.</a:t>
+              <a:t>Cuatro contenedores con una justificacion medible es mejor arquitectura que ocho por moda.</a:t>
             </a:r>
           </a:p>
           <a:p/>
           <a:p>
             <a:r>
-              <a:t>(No se proyecta) Hay una aritmetica que conviene mostrar porque impresiona con razon: si una peticion del usuario atraviesa en cadena cinco servicios y cada uno esta disponible el 99,9 % del tiempo, la disponibilidad del recorrido completo es 0,999 elevado a la quinta potencia, alrededor del 99,5 %, lo que pasa de unos 43 minutos de indisponibilidad al mes a mas de tres horas.</a:t>
+              <a:t>NOTAS:</a:t>
+            </a:r>
+          </a:p>
+          <a:p/>
+          <a:p>
+            <a:r>
+              <a:t>La flecha entre la web y la API dice «HTTPS/JSON, consulta disponibilidad y crea reservas»; la flecha entre la API y la base de datos dice «TCP, lee y escribe turnos».</a:t>
+            </a:r>
+          </a:p>
+          <a:p/>
+          <a:p>
+            <a:r>
+              <a:t>Con eso ya existe un diagrama valido y defendible.</a:t>
+            </a:r>
+          </a:p>
+          <a:p/>
+          <a:p>
+            <a:r>
+              <a:t>Si la API espera ese envio antes de responder, la reserva de un turno hereda esa latencia y ese riesgo.</a:t>
+            </a:r>
+          </a:p>
+          <a:p/>
+          <a:p>
+            <a:r>
+              <a:t>Esa es una razon legitima para separar: se agrega una cola de mensajes y un trabajador de notificaciones, la API escribe el turno, publica un mensaje y responde en decenas de milisegundos, y el trabajador envia el correo despues, con reintentos si falla.</a:t>
+            </a:r>
+          </a:p>
+          <a:p/>
+          <a:p>
+            <a:r>
+              <a:t>(No se proyecta) Primer ejemplo concreto, y conviene construirlo en el tablero en vivo.</a:t>
             </a:r>
           </a:p>
         </p:txBody>
@@ -7363,7 +7608,7 @@
         <p:spPr>
           <a:xfrm>
             <a:off x="457200" y="1261872"/>
-            <a:ext cx="11277295" cy="4798799"/>
+            <a:ext cx="6991923" cy="4566255"/>
           </a:xfrm>
           <a:prstGeom prst="roundRect">
             <a:avLst>
@@ -7408,7 +7653,7 @@
         <p:spPr>
           <a:xfrm>
             <a:off x="457200" y="1261872"/>
-            <a:ext cx="11277295" cy="365760"/>
+            <a:ext cx="6991923" cy="365760"/>
           </a:xfrm>
           <a:prstGeom prst="rect">
             <a:avLst/>
@@ -7580,7 +7825,7 @@
         <p:spPr>
           <a:xfrm>
             <a:off x="1371600" y="1298448"/>
-            <a:ext cx="10180015" cy="292608"/>
+            <a:ext cx="5894643" cy="292608"/>
           </a:xfrm>
           <a:prstGeom prst="rect">
             <a:avLst/>
@@ -7613,7 +7858,7 @@
         <p:spPr>
           <a:xfrm>
             <a:off x="685800" y="1719072"/>
-            <a:ext cx="502920" cy="4204439"/>
+            <a:ext cx="502920" cy="3971895"/>
           </a:xfrm>
           <a:prstGeom prst="rect">
             <a:avLst/>
@@ -7628,11 +7873,11 @@
           <a:p>
             <a:pPr algn="r">
               <a:spcAft>
-                <a:spcPts val="321"/>
+                <a:spcPts val="300"/>
               </a:spcAft>
             </a:pPr>
             <a:r>
-              <a:rPr sz="1500" i="0" b="0">
+              <a:rPr sz="1400" i="0" b="0">
                 <a:solidFill>
                   <a:srgbClr val="858585"/>
                 </a:solidFill>
@@ -7644,11 +7889,11 @@
           <a:p>
             <a:pPr algn="r">
               <a:spcAft>
-                <a:spcPts val="321"/>
+                <a:spcPts val="300"/>
               </a:spcAft>
             </a:pPr>
             <a:r>
-              <a:rPr sz="1500" i="0" b="0">
+              <a:rPr sz="1400" i="0" b="0">
                 <a:solidFill>
                   <a:srgbClr val="858585"/>
                 </a:solidFill>
@@ -7660,11 +7905,11 @@
           <a:p>
             <a:pPr algn="r">
               <a:spcAft>
-                <a:spcPts val="321"/>
+                <a:spcPts val="300"/>
               </a:spcAft>
             </a:pPr>
             <a:r>
-              <a:rPr sz="1500" i="0" b="0">
+              <a:rPr sz="1400" i="0" b="0">
                 <a:solidFill>
                   <a:srgbClr val="858585"/>
                 </a:solidFill>
@@ -7676,11 +7921,11 @@
           <a:p>
             <a:pPr algn="r">
               <a:spcAft>
-                <a:spcPts val="321"/>
+                <a:spcPts val="300"/>
               </a:spcAft>
             </a:pPr>
             <a:r>
-              <a:rPr sz="1500" i="0" b="0">
+              <a:rPr sz="1400" i="0" b="0">
                 <a:solidFill>
                   <a:srgbClr val="858585"/>
                 </a:solidFill>
@@ -7692,11 +7937,11 @@
           <a:p>
             <a:pPr algn="r">
               <a:spcAft>
-                <a:spcPts val="321"/>
+                <a:spcPts val="300"/>
               </a:spcAft>
             </a:pPr>
             <a:r>
-              <a:rPr sz="1500" i="0" b="0">
+              <a:rPr sz="1400" i="0" b="0">
                 <a:solidFill>
                   <a:srgbClr val="858585"/>
                 </a:solidFill>
@@ -7708,11 +7953,11 @@
           <a:p>
             <a:pPr algn="r">
               <a:spcAft>
-                <a:spcPts val="321"/>
+                <a:spcPts val="300"/>
               </a:spcAft>
             </a:pPr>
             <a:r>
-              <a:rPr sz="1500" i="0" b="0">
+              <a:rPr sz="1400" i="0" b="0">
                 <a:solidFill>
                   <a:srgbClr val="858585"/>
                 </a:solidFill>
@@ -7724,11 +7969,11 @@
           <a:p>
             <a:pPr algn="r">
               <a:spcAft>
-                <a:spcPts val="321"/>
+                <a:spcPts val="300"/>
               </a:spcAft>
             </a:pPr>
             <a:r>
-              <a:rPr sz="1500" i="0" b="0">
+              <a:rPr sz="1400" i="0" b="0">
                 <a:solidFill>
                   <a:srgbClr val="858585"/>
                 </a:solidFill>
@@ -7740,11 +7985,11 @@
           <a:p>
             <a:pPr algn="r">
               <a:spcAft>
-                <a:spcPts val="321"/>
+                <a:spcPts val="300"/>
               </a:spcAft>
             </a:pPr>
             <a:r>
-              <a:rPr sz="1500" i="0" b="0">
+              <a:rPr sz="1400" i="0" b="0">
                 <a:solidFill>
                   <a:srgbClr val="858585"/>
                 </a:solidFill>
@@ -7756,11 +8001,11 @@
           <a:p>
             <a:pPr algn="r">
               <a:spcAft>
-                <a:spcPts val="321"/>
+                <a:spcPts val="300"/>
               </a:spcAft>
             </a:pPr>
             <a:r>
-              <a:rPr sz="1500" i="0" b="0">
+              <a:rPr sz="1400" i="0" b="0">
                 <a:solidFill>
                   <a:srgbClr val="858585"/>
                 </a:solidFill>
@@ -7772,11 +8017,11 @@
           <a:p>
             <a:pPr algn="r">
               <a:spcAft>
-                <a:spcPts val="321"/>
+                <a:spcPts val="300"/>
               </a:spcAft>
             </a:pPr>
             <a:r>
-              <a:rPr sz="1500" i="0" b="0">
+              <a:rPr sz="1400" i="0" b="0">
                 <a:solidFill>
                   <a:srgbClr val="858585"/>
                 </a:solidFill>
@@ -7788,11 +8033,11 @@
           <a:p>
             <a:pPr algn="r">
               <a:spcAft>
-                <a:spcPts val="321"/>
+                <a:spcPts val="300"/>
               </a:spcAft>
             </a:pPr>
             <a:r>
-              <a:rPr sz="1500" i="0" b="0">
+              <a:rPr sz="1400" i="0" b="0">
                 <a:solidFill>
                   <a:srgbClr val="858585"/>
                 </a:solidFill>
@@ -7804,11 +8049,11 @@
           <a:p>
             <a:pPr algn="r">
               <a:spcAft>
-                <a:spcPts val="321"/>
+                <a:spcPts val="300"/>
               </a:spcAft>
             </a:pPr>
             <a:r>
-              <a:rPr sz="1500" i="0" b="0">
+              <a:rPr sz="1400" i="0" b="0">
                 <a:solidFill>
                   <a:srgbClr val="858585"/>
                 </a:solidFill>
@@ -7820,11 +8065,11 @@
           <a:p>
             <a:pPr algn="r">
               <a:spcAft>
-                <a:spcPts val="321"/>
+                <a:spcPts val="300"/>
               </a:spcAft>
             </a:pPr>
             <a:r>
-              <a:rPr sz="1500" i="0" b="0">
+              <a:rPr sz="1400" i="0" b="0">
                 <a:solidFill>
                   <a:srgbClr val="858585"/>
                 </a:solidFill>
@@ -7836,11 +8081,11 @@
           <a:p>
             <a:pPr algn="r">
               <a:spcAft>
-                <a:spcPts val="321"/>
+                <a:spcPts val="300"/>
               </a:spcAft>
             </a:pPr>
             <a:r>
-              <a:rPr sz="1500" i="0" b="0">
+              <a:rPr sz="1400" i="0" b="0">
                 <a:solidFill>
                   <a:srgbClr val="858585"/>
                 </a:solidFill>
@@ -7852,11 +8097,11 @@
           <a:p>
             <a:pPr algn="r">
               <a:spcAft>
-                <a:spcPts val="321"/>
+                <a:spcPts val="300"/>
               </a:spcAft>
             </a:pPr>
             <a:r>
-              <a:rPr sz="1500" i="0" b="0">
+              <a:rPr sz="1400" i="0" b="0">
                 <a:solidFill>
                   <a:srgbClr val="858585"/>
                 </a:solidFill>
@@ -7876,7 +8121,7 @@
         <p:spPr>
           <a:xfrm>
             <a:off x="1188720" y="1719072"/>
-            <a:ext cx="10271455" cy="4204439"/>
+            <a:ext cx="5986083" cy="3971895"/>
           </a:xfrm>
           <a:prstGeom prst="rect">
             <a:avLst/>
@@ -7891,11 +8136,11 @@
           <a:p>
             <a:pPr>
               <a:spcAft>
-                <a:spcPts val="321"/>
+                <a:spcPts val="300"/>
               </a:spcAft>
             </a:pPr>
             <a:r>
-              <a:rPr sz="1500" i="0" b="0">
+              <a:rPr sz="1400" i="0" b="0">
                 <a:solidFill>
                   <a:srgbClr val="D4D4D4"/>
                 </a:solidFill>
@@ -7907,11 +8152,11 @@
           <a:p>
             <a:pPr>
               <a:spcAft>
-                <a:spcPts val="321"/>
+                <a:spcPts val="300"/>
               </a:spcAft>
             </a:pPr>
             <a:r>
-              <a:rPr sz="1500" i="0" b="0">
+              <a:rPr sz="1400" i="0" b="0">
                 <a:solidFill>
                   <a:srgbClr val="D4D4D4"/>
                 </a:solidFill>
@@ -7920,7 +8165,7 @@
               <a:t>title</a:t>
             </a:r>
             <a:r>
-              <a:rPr sz="1500" i="0" b="0">
+              <a:rPr sz="1400" i="0" b="0">
                 <a:solidFill>
                   <a:srgbClr val="D4D4D4"/>
                 </a:solidFill>
@@ -7929,25 +8174,43 @@
               <a:t> </a:t>
             </a:r>
             <a:r>
-              <a:rPr sz="1500" i="0" b="0">
+              <a:rPr sz="1400" i="0" b="0">
                 <a:solidFill>
                   <a:srgbClr val="D4D4D4"/>
                 </a:solidFill>
                 <a:latin typeface="Consolas"/>
               </a:rPr>
-              <a:t>Diagrama</a:t>
-            </a:r>
-            <a:r>
-              <a:rPr sz="1500" i="0" b="0">
+              <a:t>Contenedores</a:t>
+            </a:r>
+            <a:r>
+              <a:rPr sz="1400" i="0" b="0">
                 <a:solidFill>
                   <a:srgbClr val="D4D4D4"/>
                 </a:solidFill>
                 <a:latin typeface="Consolas"/>
               </a:rPr>
+              <a:t> - </a:t>
+            </a:r>
+            <a:r>
+              <a:rPr sz="1400" i="0" b="0">
+                <a:solidFill>
+                  <a:srgbClr val="D4D4D4"/>
+                </a:solidFill>
+                <a:latin typeface="Consolas"/>
+              </a:rPr>
+              <a:t>App</a:t>
+            </a:r>
+            <a:r>
+              <a:rPr sz="1400" i="0" b="0">
+                <a:solidFill>
+                  <a:srgbClr val="D4D4D4"/>
+                </a:solidFill>
+                <a:latin typeface="Consolas"/>
+              </a:rPr>
               <a:t> </a:t>
             </a:r>
             <a:r>
-              <a:rPr sz="1500" i="0" b="0">
+              <a:rPr sz="1400" i="0" b="0">
                 <a:solidFill>
                   <a:srgbClr val="D4D4D4"/>
                 </a:solidFill>
@@ -7956,7 +8219,7 @@
               <a:t>de</a:t>
             </a:r>
             <a:r>
-              <a:rPr sz="1500" i="0" b="0">
+              <a:rPr sz="1400" i="0" b="0">
                 <a:solidFill>
                   <a:srgbClr val="D4D4D4"/>
                 </a:solidFill>
@@ -7965,59 +8228,23 @@
               <a:t> </a:t>
             </a:r>
             <a:r>
-              <a:rPr sz="1500" i="0" b="0">
+              <a:rPr sz="1400" i="0" b="0">
                 <a:solidFill>
                   <a:srgbClr val="D4D4D4"/>
                 </a:solidFill>
                 <a:latin typeface="Consolas"/>
               </a:rPr>
-              <a:t>contenedores</a:t>
-            </a:r>
-            <a:r>
-              <a:rPr sz="1500" i="0" b="0">
-                <a:solidFill>
-                  <a:srgbClr val="D4D4D4"/>
-                </a:solidFill>
-                <a:latin typeface="Consolas"/>
-              </a:rPr>
-              <a:t> - </a:t>
-            </a:r>
-            <a:r>
-              <a:rPr sz="1500" i="0" b="0">
-                <a:solidFill>
-                  <a:srgbClr val="D4D4D4"/>
-                </a:solidFill>
-                <a:latin typeface="Consolas"/>
-              </a:rPr>
-              <a:t>La app</a:t>
-            </a:r>
-            <a:r>
-              <a:rPr sz="1500" i="0" b="0">
-                <a:solidFill>
-                  <a:srgbClr val="D4D4D4"/>
-                </a:solidFill>
-                <a:latin typeface="Consolas"/>
-              </a:rPr>
-              <a:t> </a:t>
-            </a:r>
-            <a:r>
-              <a:rPr sz="1500" i="0" b="0">
-                <a:solidFill>
-                  <a:srgbClr val="D4D4D4"/>
-                </a:solidFill>
-                <a:latin typeface="Consolas"/>
-              </a:rPr>
-              <a:t>Turnos</a:t>
+              <a:t>turnos</a:t>
             </a:r>
           </a:p>
           <a:p>
             <a:pPr>
               <a:spcAft>
-                <a:spcPts val="321"/>
+                <a:spcPts val="300"/>
               </a:spcAft>
             </a:pPr>
             <a:r>
-              <a:rPr sz="1500" i="0" b="0">
+              <a:rPr sz="1400" i="0" b="0">
                 <a:solidFill>
                   <a:srgbClr val="DCDCAA"/>
                 </a:solidFill>
@@ -8026,7 +8253,7 @@
               <a:t>Person</a:t>
             </a:r>
             <a:r>
-              <a:rPr sz="1500" i="0" b="0">
+              <a:rPr sz="1400" i="0" b="0">
                 <a:solidFill>
                   <a:srgbClr val="D4D4D4"/>
                 </a:solidFill>
@@ -8035,7 +8262,7 @@
               <a:t>(</a:t>
             </a:r>
             <a:r>
-              <a:rPr sz="1500" i="0" b="0">
+              <a:rPr sz="1400" i="0" b="0">
                 <a:solidFill>
                   <a:srgbClr val="D4D4D4"/>
                 </a:solidFill>
@@ -8044,7 +8271,7 @@
               <a:t>cliente</a:t>
             </a:r>
             <a:r>
-              <a:rPr sz="1500" i="0" b="0">
+              <a:rPr sz="1400" i="0" b="0">
                 <a:solidFill>
                   <a:srgbClr val="D4D4D4"/>
                 </a:solidFill>
@@ -8053,16 +8280,16 @@
               <a:t>, </a:t>
             </a:r>
             <a:r>
-              <a:rPr sz="1500" i="0" b="0">
+              <a:rPr sz="1400" i="0" b="0">
                 <a:solidFill>
                   <a:srgbClr val="CE9178"/>
                 </a:solidFill>
                 <a:latin typeface="Consolas"/>
               </a:rPr>
-              <a:t>"Cliente de la barberia"</a:t>
-            </a:r>
-            <a:r>
-              <a:rPr sz="1500" i="0" b="0">
+              <a:t>"Cliente"</a:t>
+            </a:r>
+            <a:r>
+              <a:rPr sz="1400" i="0" b="0">
                 <a:solidFill>
                   <a:srgbClr val="D4D4D4"/>
                 </a:solidFill>
@@ -8071,16 +8298,16 @@
               <a:t>, </a:t>
             </a:r>
             <a:r>
-              <a:rPr sz="1500" i="0" b="0">
+              <a:rPr sz="1400" i="0" b="0">
                 <a:solidFill>
                   <a:srgbClr val="CE9178"/>
                 </a:solidFill>
                 <a:latin typeface="Consolas"/>
               </a:rPr>
-              <a:t>"Reserva y consulta sus turnos"</a:t>
-            </a:r>
-            <a:r>
-              <a:rPr sz="1500" i="0" b="0">
+              <a:t>"Reserva sus turnos"</a:t>
+            </a:r>
+            <a:r>
+              <a:rPr sz="1400" i="0" b="0">
                 <a:solidFill>
                   <a:srgbClr val="D4D4D4"/>
                 </a:solidFill>
@@ -8092,11 +8319,11 @@
           <a:p>
             <a:pPr>
               <a:spcAft>
-                <a:spcPts val="321"/>
+                <a:spcPts val="300"/>
               </a:spcAft>
             </a:pPr>
             <a:r>
-              <a:rPr sz="1500" i="0" b="0">
+              <a:rPr sz="1400" i="0" b="0">
                 <a:solidFill>
                   <a:srgbClr val="DCDCAA"/>
                 </a:solidFill>
@@ -8105,7 +8332,7 @@
               <a:t>System_Boundary</a:t>
             </a:r>
             <a:r>
-              <a:rPr sz="1500" i="0" b="0">
+              <a:rPr sz="1400" i="0" b="0">
                 <a:solidFill>
                   <a:srgbClr val="D4D4D4"/>
                 </a:solidFill>
@@ -8114,16 +8341,16 @@
               <a:t>(</a:t>
             </a:r>
             <a:r>
-              <a:rPr sz="1500" i="0" b="0">
+              <a:rPr sz="1400" i="0" b="0">
                 <a:solidFill>
                   <a:srgbClr val="D4D4D4"/>
                 </a:solidFill>
                 <a:latin typeface="Consolas"/>
               </a:rPr>
-              <a:t>turnos</a:t>
-            </a:r>
-            <a:r>
-              <a:rPr sz="1500" i="0" b="0">
+              <a:t>app</a:t>
+            </a:r>
+            <a:r>
+              <a:rPr sz="1400" i="0" b="0">
                 <a:solidFill>
                   <a:srgbClr val="D4D4D4"/>
                 </a:solidFill>
@@ -8132,16 +8359,16 @@
               <a:t>, </a:t>
             </a:r>
             <a:r>
-              <a:rPr sz="1500" i="0" b="0">
+              <a:rPr sz="1400" i="0" b="0">
                 <a:solidFill>
                   <a:srgbClr val="CE9178"/>
                 </a:solidFill>
                 <a:latin typeface="Consolas"/>
               </a:rPr>
-              <a:t>"la app"</a:t>
-            </a:r>
-            <a:r>
-              <a:rPr sz="1500" i="0" b="0">
+              <a:t>"App de turnos"</a:t>
+            </a:r>
+            <a:r>
+              <a:rPr sz="1400" i="0" b="0">
                 <a:solidFill>
                   <a:srgbClr val="D4D4D4"/>
                 </a:solidFill>
@@ -8153,11 +8380,11 @@
           <a:p>
             <a:pPr>
               <a:spcAft>
-                <a:spcPts val="321"/>
+                <a:spcPts val="300"/>
               </a:spcAft>
             </a:pPr>
             <a:r>
-              <a:rPr sz="1500" i="0" b="0">
+              <a:rPr sz="1400" i="0" b="0">
                 <a:solidFill>
                   <a:srgbClr val="D4D4D4"/>
                 </a:solidFill>
@@ -8166,7 +8393,7 @@
               <a:t>  </a:t>
             </a:r>
             <a:r>
-              <a:rPr sz="1500" i="0" b="0">
+              <a:rPr sz="1400" i="0" b="0">
                 <a:solidFill>
                   <a:srgbClr val="DCDCAA"/>
                 </a:solidFill>
@@ -8175,7 +8402,7 @@
               <a:t>Container</a:t>
             </a:r>
             <a:r>
-              <a:rPr sz="1500" i="0" b="0">
+              <a:rPr sz="1400" i="0" b="0">
                 <a:solidFill>
                   <a:srgbClr val="D4D4D4"/>
                 </a:solidFill>
@@ -8184,7 +8411,7 @@
               <a:t>(</a:t>
             </a:r>
             <a:r>
-              <a:rPr sz="1500" i="0" b="0">
+              <a:rPr sz="1400" i="0" b="0">
                 <a:solidFill>
                   <a:srgbClr val="D4D4D4"/>
                 </a:solidFill>
@@ -8193,7 +8420,7 @@
               <a:t>spa</a:t>
             </a:r>
             <a:r>
-              <a:rPr sz="1500" i="0" b="0">
+              <a:rPr sz="1400" i="0" b="0">
                 <a:solidFill>
                   <a:srgbClr val="D4D4D4"/>
                 </a:solidFill>
@@ -8202,7 +8429,7 @@
               <a:t>, </a:t>
             </a:r>
             <a:r>
-              <a:rPr sz="1500" i="0" b="0">
+              <a:rPr sz="1400" i="0" b="0">
                 <a:solidFill>
                   <a:srgbClr val="CE9178"/>
                 </a:solidFill>
@@ -8211,7 +8438,7 @@
               <a:t>"App web"</a:t>
             </a:r>
             <a:r>
-              <a:rPr sz="1500" i="0" b="0">
+              <a:rPr sz="1400" i="0" b="0">
                 <a:solidFill>
                   <a:srgbClr val="D4D4D4"/>
                 </a:solidFill>
@@ -8220,7 +8447,7 @@
               <a:t>, </a:t>
             </a:r>
             <a:r>
-              <a:rPr sz="1500" i="0" b="0">
+              <a:rPr sz="1400" i="0" b="0">
                 <a:solidFill>
                   <a:srgbClr val="CE9178"/>
                 </a:solidFill>
@@ -8229,7 +8456,7 @@
               <a:t>"React"</a:t>
             </a:r>
             <a:r>
-              <a:rPr sz="1500" i="0" b="0">
+              <a:rPr sz="1400" i="0" b="0">
                 <a:solidFill>
                   <a:srgbClr val="D4D4D4"/>
                 </a:solidFill>
@@ -8238,16 +8465,16 @@
               <a:t>, </a:t>
             </a:r>
             <a:r>
-              <a:rPr sz="1500" i="0" b="0">
+              <a:rPr sz="1400" i="0" b="0">
                 <a:solidFill>
                   <a:srgbClr val="CE9178"/>
                 </a:solidFill>
                 <a:latin typeface="Consolas"/>
               </a:rPr>
-              <a:t>"Muestra franjas libres y crea la reserva"</a:t>
-            </a:r>
-            <a:r>
-              <a:rPr sz="1500" i="0" b="0">
+              <a:t>"Reserva"</a:t>
+            </a:r>
+            <a:r>
+              <a:rPr sz="1400" i="0" b="0">
                 <a:solidFill>
                   <a:srgbClr val="D4D4D4"/>
                 </a:solidFill>
@@ -8259,11 +8486,11 @@
           <a:p>
             <a:pPr>
               <a:spcAft>
-                <a:spcPts val="321"/>
+                <a:spcPts val="300"/>
               </a:spcAft>
             </a:pPr>
             <a:r>
-              <a:rPr sz="1500" i="0" b="0">
+              <a:rPr sz="1400" i="0" b="0">
                 <a:solidFill>
                   <a:srgbClr val="D4D4D4"/>
                 </a:solidFill>
@@ -8272,7 +8499,7 @@
               <a:t>  </a:t>
             </a:r>
             <a:r>
-              <a:rPr sz="1500" i="0" b="0">
+              <a:rPr sz="1400" i="0" b="0">
                 <a:solidFill>
                   <a:srgbClr val="DCDCAA"/>
                 </a:solidFill>
@@ -8281,7 +8508,7 @@
               <a:t>Container</a:t>
             </a:r>
             <a:r>
-              <a:rPr sz="1500" i="0" b="0">
+              <a:rPr sz="1400" i="0" b="0">
                 <a:solidFill>
                   <a:srgbClr val="D4D4D4"/>
                 </a:solidFill>
@@ -8290,7 +8517,7 @@
               <a:t>(</a:t>
             </a:r>
             <a:r>
-              <a:rPr sz="1500" i="0" b="0">
+              <a:rPr sz="1400" i="0" b="0">
                 <a:solidFill>
                   <a:srgbClr val="D4D4D4"/>
                 </a:solidFill>
@@ -8299,7 +8526,7 @@
               <a:t>api</a:t>
             </a:r>
             <a:r>
-              <a:rPr sz="1500" i="0" b="0">
+              <a:rPr sz="1400" i="0" b="0">
                 <a:solidFill>
                   <a:srgbClr val="D4D4D4"/>
                 </a:solidFill>
@@ -8308,7 +8535,7 @@
               <a:t>, </a:t>
             </a:r>
             <a:r>
-              <a:rPr sz="1500" i="0" b="0">
+              <a:rPr sz="1400" i="0" b="0">
                 <a:solidFill>
                   <a:srgbClr val="CE9178"/>
                 </a:solidFill>
@@ -8317,7 +8544,7 @@
               <a:t>"API de turnos"</a:t>
             </a:r>
             <a:r>
-              <a:rPr sz="1500" i="0" b="0">
+              <a:rPr sz="1400" i="0" b="0">
                 <a:solidFill>
                   <a:srgbClr val="D4D4D4"/>
                 </a:solidFill>
@@ -8326,7 +8553,7 @@
               <a:t>, </a:t>
             </a:r>
             <a:r>
-              <a:rPr sz="1500" i="0" b="0">
+              <a:rPr sz="1400" i="0" b="0">
                 <a:solidFill>
                   <a:srgbClr val="CE9178"/>
                 </a:solidFill>
@@ -8335,7 +8562,7 @@
               <a:t>"Node.js"</a:t>
             </a:r>
             <a:r>
-              <a:rPr sz="1500" i="0" b="0">
+              <a:rPr sz="1400" i="0" b="0">
                 <a:solidFill>
                   <a:srgbClr val="D4D4D4"/>
                 </a:solidFill>
@@ -8344,16 +8571,16 @@
               <a:t>, </a:t>
             </a:r>
             <a:r>
-              <a:rPr sz="1500" i="0" b="0">
+              <a:rPr sz="1400" i="0" b="0">
                 <a:solidFill>
                   <a:srgbClr val="CE9178"/>
                 </a:solidFill>
                 <a:latin typeface="Consolas"/>
               </a:rPr>
-              <a:t>"Valida la franja y registra el turno"</a:t>
-            </a:r>
-            <a:r>
-              <a:rPr sz="1500" i="0" b="0">
+              <a:t>"Valida"</a:t>
+            </a:r>
+            <a:r>
+              <a:rPr sz="1400" i="0" b="0">
                 <a:solidFill>
                   <a:srgbClr val="D4D4D4"/>
                 </a:solidFill>
@@ -8365,11 +8592,11 @@
           <a:p>
             <a:pPr>
               <a:spcAft>
-                <a:spcPts val="321"/>
+                <a:spcPts val="300"/>
               </a:spcAft>
             </a:pPr>
             <a:r>
-              <a:rPr sz="1500" i="0" b="0">
+              <a:rPr sz="1400" i="0" b="0">
                 <a:solidFill>
                   <a:srgbClr val="D4D4D4"/>
                 </a:solidFill>
@@ -8378,7 +8605,7 @@
               <a:t>  </a:t>
             </a:r>
             <a:r>
-              <a:rPr sz="1500" i="0" b="0">
+              <a:rPr sz="1400" i="0" b="0">
                 <a:solidFill>
                   <a:srgbClr val="DCDCAA"/>
                 </a:solidFill>
@@ -8387,7 +8614,7 @@
               <a:t>ContainerDb</a:t>
             </a:r>
             <a:r>
-              <a:rPr sz="1500" i="0" b="0">
+              <a:rPr sz="1400" i="0" b="0">
                 <a:solidFill>
                   <a:srgbClr val="D4D4D4"/>
                 </a:solidFill>
@@ -8396,7 +8623,7 @@
               <a:t>(</a:t>
             </a:r>
             <a:r>
-              <a:rPr sz="1500" i="0" b="0">
+              <a:rPr sz="1400" i="0" b="0">
                 <a:solidFill>
                   <a:srgbClr val="D4D4D4"/>
                 </a:solidFill>
@@ -8405,7 +8632,7 @@
               <a:t>db</a:t>
             </a:r>
             <a:r>
-              <a:rPr sz="1500" i="0" b="0">
+              <a:rPr sz="1400" i="0" b="0">
                 <a:solidFill>
                   <a:srgbClr val="D4D4D4"/>
                 </a:solidFill>
@@ -8414,7 +8641,7 @@
               <a:t>, </a:t>
             </a:r>
             <a:r>
-              <a:rPr sz="1500" i="0" b="0">
+              <a:rPr sz="1400" i="0" b="0">
                 <a:solidFill>
                   <a:srgbClr val="CE9178"/>
                 </a:solidFill>
@@ -8423,7 +8650,7 @@
               <a:t>"Base de turnos"</a:t>
             </a:r>
             <a:r>
-              <a:rPr sz="1500" i="0" b="0">
+              <a:rPr sz="1400" i="0" b="0">
                 <a:solidFill>
                   <a:srgbClr val="D4D4D4"/>
                 </a:solidFill>
@@ -8432,7 +8659,7 @@
               <a:t>, </a:t>
             </a:r>
             <a:r>
-              <a:rPr sz="1500" i="0" b="0">
+              <a:rPr sz="1400" i="0" b="0">
                 <a:solidFill>
                   <a:srgbClr val="CE9178"/>
                 </a:solidFill>
@@ -8441,25 +8668,7 @@
               <a:t>"PostgreSQL"</a:t>
             </a:r>
             <a:r>
-              <a:rPr sz="1500" i="0" b="0">
-                <a:solidFill>
-                  <a:srgbClr val="D4D4D4"/>
-                </a:solidFill>
-                <a:latin typeface="Consolas"/>
-              </a:rPr>
-              <a:t>, </a:t>
-            </a:r>
-            <a:r>
-              <a:rPr sz="1500" i="0" b="0">
-                <a:solidFill>
-                  <a:srgbClr val="CE9178"/>
-                </a:solidFill>
-                <a:latin typeface="Consolas"/>
-              </a:rPr>
-              <a:t>"Turnos, clientes y horarios"</a:t>
-            </a:r>
-            <a:r>
-              <a:rPr sz="1500" i="0" b="0">
+              <a:rPr sz="1400" i="0" b="0">
                 <a:solidFill>
                   <a:srgbClr val="D4D4D4"/>
                 </a:solidFill>
@@ -8471,11 +8680,11 @@
           <a:p>
             <a:pPr>
               <a:spcAft>
-                <a:spcPts val="321"/>
+                <a:spcPts val="300"/>
               </a:spcAft>
             </a:pPr>
             <a:r>
-              <a:rPr sz="1500" i="0" b="0">
+              <a:rPr sz="1400" i="0" b="0">
                 <a:solidFill>
                   <a:srgbClr val="D4D4D4"/>
                 </a:solidFill>
@@ -8484,7 +8693,7 @@
               <a:t>  </a:t>
             </a:r>
             <a:r>
-              <a:rPr sz="1500" i="0" b="0">
+              <a:rPr sz="1400" i="0" b="0">
                 <a:solidFill>
                   <a:srgbClr val="DCDCAA"/>
                 </a:solidFill>
@@ -8493,7 +8702,7 @@
               <a:t>Container</a:t>
             </a:r>
             <a:r>
-              <a:rPr sz="1500" i="0" b="0">
+              <a:rPr sz="1400" i="0" b="0">
                 <a:solidFill>
                   <a:srgbClr val="D4D4D4"/>
                 </a:solidFill>
@@ -8502,7 +8711,7 @@
               <a:t>(</a:t>
             </a:r>
             <a:r>
-              <a:rPr sz="1500" i="0" b="0">
+              <a:rPr sz="1400" i="0" b="0">
                 <a:solidFill>
                   <a:srgbClr val="D4D4D4"/>
                 </a:solidFill>
@@ -8511,7 +8720,7 @@
               <a:t>worker</a:t>
             </a:r>
             <a:r>
-              <a:rPr sz="1500" i="0" b="0">
+              <a:rPr sz="1400" i="0" b="0">
                 <a:solidFill>
                   <a:srgbClr val="D4D4D4"/>
                 </a:solidFill>
@@ -8520,16 +8729,16 @@
               <a:t>, </a:t>
             </a:r>
             <a:r>
-              <a:rPr sz="1500" i="0" b="0">
+              <a:rPr sz="1400" i="0" b="0">
                 <a:solidFill>
                   <a:srgbClr val="CE9178"/>
                 </a:solidFill>
                 <a:latin typeface="Consolas"/>
               </a:rPr>
-              <a:t>"Worker de avisos"</a:t>
-            </a:r>
-            <a:r>
-              <a:rPr sz="1500" i="0" b="0">
+              <a:t>"Worker"</a:t>
+            </a:r>
+            <a:r>
+              <a:rPr sz="1400" i="0" b="0">
                 <a:solidFill>
                   <a:srgbClr val="D4D4D4"/>
                 </a:solidFill>
@@ -8538,7 +8747,7 @@
               <a:t>, </a:t>
             </a:r>
             <a:r>
-              <a:rPr sz="1500" i="0" b="0">
+              <a:rPr sz="1400" i="0" b="0">
                 <a:solidFill>
                   <a:srgbClr val="CE9178"/>
                 </a:solidFill>
@@ -8547,7 +8756,7 @@
               <a:t>"cola"</a:t>
             </a:r>
             <a:r>
-              <a:rPr sz="1500" i="0" b="0">
+              <a:rPr sz="1400" i="0" b="0">
                 <a:solidFill>
                   <a:srgbClr val="D4D4D4"/>
                 </a:solidFill>
@@ -8556,16 +8765,16 @@
               <a:t>, </a:t>
             </a:r>
             <a:r>
-              <a:rPr sz="1500" i="0" b="0">
+              <a:rPr sz="1400" i="0" b="0">
                 <a:solidFill>
                   <a:srgbClr val="CE9178"/>
                 </a:solidFill>
                 <a:latin typeface="Consolas"/>
               </a:rPr>
-              <a:t>"Envia el aviso, con reintentos"</a:t>
-            </a:r>
-            <a:r>
-              <a:rPr sz="1500" i="0" b="0">
+              <a:t>"Avisos"</a:t>
+            </a:r>
+            <a:r>
+              <a:rPr sz="1400" i="0" b="0">
                 <a:solidFill>
                   <a:srgbClr val="D4D4D4"/>
                 </a:solidFill>
@@ -8577,11 +8786,11 @@
           <a:p>
             <a:pPr>
               <a:spcAft>
-                <a:spcPts val="321"/>
+                <a:spcPts val="300"/>
               </a:spcAft>
             </a:pPr>
             <a:r>
-              <a:rPr sz="1500" i="0" b="0">
+              <a:rPr sz="1400" i="0" b="0">
                 <a:solidFill>
                   <a:srgbClr val="D4D4D4"/>
                 </a:solidFill>
@@ -8593,11 +8802,11 @@
           <a:p>
             <a:pPr>
               <a:spcAft>
-                <a:spcPts val="321"/>
+                <a:spcPts val="300"/>
               </a:spcAft>
             </a:pPr>
             <a:r>
-              <a:rPr sz="1500" i="0" b="0">
+              <a:rPr sz="1400" i="0" b="0">
                 <a:solidFill>
                   <a:srgbClr val="DCDCAA"/>
                 </a:solidFill>
@@ -8606,7 +8815,7 @@
               <a:t>System_Ext</a:t>
             </a:r>
             <a:r>
-              <a:rPr sz="1500" i="0" b="0">
+              <a:rPr sz="1400" i="0" b="0">
                 <a:solidFill>
                   <a:srgbClr val="D4D4D4"/>
                 </a:solidFill>
@@ -8615,7 +8824,7 @@
               <a:t>(</a:t>
             </a:r>
             <a:r>
-              <a:rPr sz="1500" i="0" b="0">
+              <a:rPr sz="1400" i="0" b="0">
                 <a:solidFill>
                   <a:srgbClr val="D4D4D4"/>
                 </a:solidFill>
@@ -8624,7 +8833,7 @@
               <a:t>correo</a:t>
             </a:r>
             <a:r>
-              <a:rPr sz="1500" i="0" b="0">
+              <a:rPr sz="1400" i="0" b="0">
                 <a:solidFill>
                   <a:srgbClr val="D4D4D4"/>
                 </a:solidFill>
@@ -8633,16 +8842,16 @@
               <a:t>, </a:t>
             </a:r>
             <a:r>
-              <a:rPr sz="1500" i="0" b="0">
+              <a:rPr sz="1400" i="0" b="0">
                 <a:solidFill>
                   <a:srgbClr val="CE9178"/>
                 </a:solidFill>
                 <a:latin typeface="Consolas"/>
               </a:rPr>
-              <a:t>"Correo transaccional"</a:t>
-            </a:r>
-            <a:r>
-              <a:rPr sz="1500" i="0" b="0">
+              <a:t>"Correo"</a:t>
+            </a:r>
+            <a:r>
+              <a:rPr sz="1400" i="0" b="0">
                 <a:solidFill>
                   <a:srgbClr val="D4D4D4"/>
                 </a:solidFill>
@@ -8651,16 +8860,16 @@
               <a:t>, </a:t>
             </a:r>
             <a:r>
-              <a:rPr sz="1500" i="0" b="0">
+              <a:rPr sz="1400" i="0" b="0">
                 <a:solidFill>
                   <a:srgbClr val="CE9178"/>
                 </a:solidFill>
                 <a:latin typeface="Consolas"/>
               </a:rPr>
-              <a:t>"Entrega el correo al cliente"</a:t>
-            </a:r>
-            <a:r>
-              <a:rPr sz="1500" i="0" b="0">
+              <a:t>"Entrega el correo"</a:t>
+            </a:r>
+            <a:r>
+              <a:rPr sz="1400" i="0" b="0">
                 <a:solidFill>
                   <a:srgbClr val="D4D4D4"/>
                 </a:solidFill>
@@ -8672,11 +8881,11 @@
           <a:p>
             <a:pPr>
               <a:spcAft>
-                <a:spcPts val="321"/>
+                <a:spcPts val="300"/>
               </a:spcAft>
             </a:pPr>
             <a:r>
-              <a:rPr sz="1500" i="0" b="0">
+              <a:rPr sz="1400" i="0" b="0">
                 <a:solidFill>
                   <a:srgbClr val="DCDCAA"/>
                 </a:solidFill>
@@ -8685,7 +8894,7 @@
               <a:t>Rel</a:t>
             </a:r>
             <a:r>
-              <a:rPr sz="1500" i="0" b="0">
+              <a:rPr sz="1400" i="0" b="0">
                 <a:solidFill>
                   <a:srgbClr val="D4D4D4"/>
                 </a:solidFill>
@@ -8694,7 +8903,7 @@
               <a:t>(</a:t>
             </a:r>
             <a:r>
-              <a:rPr sz="1500" i="0" b="0">
+              <a:rPr sz="1400" i="0" b="0">
                 <a:solidFill>
                   <a:srgbClr val="D4D4D4"/>
                 </a:solidFill>
@@ -8703,7 +8912,7 @@
               <a:t>cliente</a:t>
             </a:r>
             <a:r>
-              <a:rPr sz="1500" i="0" b="0">
+              <a:rPr sz="1400" i="0" b="0">
                 <a:solidFill>
                   <a:srgbClr val="D4D4D4"/>
                 </a:solidFill>
@@ -8712,7 +8921,7 @@
               <a:t>, </a:t>
             </a:r>
             <a:r>
-              <a:rPr sz="1500" i="0" b="0">
+              <a:rPr sz="1400" i="0" b="0">
                 <a:solidFill>
                   <a:srgbClr val="D4D4D4"/>
                 </a:solidFill>
@@ -8721,7 +8930,7 @@
               <a:t>spa</a:t>
             </a:r>
             <a:r>
-              <a:rPr sz="1500" i="0" b="0">
+              <a:rPr sz="1400" i="0" b="0">
                 <a:solidFill>
                   <a:srgbClr val="D4D4D4"/>
                 </a:solidFill>
@@ -8730,7 +8939,7 @@
               <a:t>, </a:t>
             </a:r>
             <a:r>
-              <a:rPr sz="1500" i="0" b="0">
+              <a:rPr sz="1400" i="0" b="0">
                 <a:solidFill>
                   <a:srgbClr val="CE9178"/>
                 </a:solidFill>
@@ -8739,7 +8948,7 @@
               <a:t>"Reserva un turno"</a:t>
             </a:r>
             <a:r>
-              <a:rPr sz="1500" i="0" b="0">
+              <a:rPr sz="1400" i="0" b="0">
                 <a:solidFill>
                   <a:srgbClr val="D4D4D4"/>
                 </a:solidFill>
@@ -8748,7 +8957,7 @@
               <a:t>, </a:t>
             </a:r>
             <a:r>
-              <a:rPr sz="1500" i="0" b="0">
+              <a:rPr sz="1400" i="0" b="0">
                 <a:solidFill>
                   <a:srgbClr val="CE9178"/>
                 </a:solidFill>
@@ -8757,7 +8966,7 @@
               <a:t>"HTTPS"</a:t>
             </a:r>
             <a:r>
-              <a:rPr sz="1500" i="0" b="0">
+              <a:rPr sz="1400" i="0" b="0">
                 <a:solidFill>
                   <a:srgbClr val="D4D4D4"/>
                 </a:solidFill>
@@ -8769,11 +8978,11 @@
           <a:p>
             <a:pPr>
               <a:spcAft>
-                <a:spcPts val="321"/>
+                <a:spcPts val="300"/>
               </a:spcAft>
             </a:pPr>
             <a:r>
-              <a:rPr sz="1500" i="0" b="0">
+              <a:rPr sz="1400" i="0" b="0">
                 <a:solidFill>
                   <a:srgbClr val="DCDCAA"/>
                 </a:solidFill>
@@ -8782,7 +8991,7 @@
               <a:t>Rel</a:t>
             </a:r>
             <a:r>
-              <a:rPr sz="1500" i="0" b="0">
+              <a:rPr sz="1400" i="0" b="0">
                 <a:solidFill>
                   <a:srgbClr val="D4D4D4"/>
                 </a:solidFill>
@@ -8791,7 +9000,7 @@
               <a:t>(</a:t>
             </a:r>
             <a:r>
-              <a:rPr sz="1500" i="0" b="0">
+              <a:rPr sz="1400" i="0" b="0">
                 <a:solidFill>
                   <a:srgbClr val="D4D4D4"/>
                 </a:solidFill>
@@ -8800,7 +9009,7 @@
               <a:t>spa</a:t>
             </a:r>
             <a:r>
-              <a:rPr sz="1500" i="0" b="0">
+              <a:rPr sz="1400" i="0" b="0">
                 <a:solidFill>
                   <a:srgbClr val="D4D4D4"/>
                 </a:solidFill>
@@ -8809,7 +9018,7 @@
               <a:t>, </a:t>
             </a:r>
             <a:r>
-              <a:rPr sz="1500" i="0" b="0">
+              <a:rPr sz="1400" i="0" b="0">
                 <a:solidFill>
                   <a:srgbClr val="D4D4D4"/>
                 </a:solidFill>
@@ -8818,7 +9027,7 @@
               <a:t>api</a:t>
             </a:r>
             <a:r>
-              <a:rPr sz="1500" i="0" b="0">
+              <a:rPr sz="1400" i="0" b="0">
                 <a:solidFill>
                   <a:srgbClr val="D4D4D4"/>
                 </a:solidFill>
@@ -8827,7 +9036,7 @@
               <a:t>, </a:t>
             </a:r>
             <a:r>
-              <a:rPr sz="1500" i="0" b="0">
+              <a:rPr sz="1400" i="0" b="0">
                 <a:solidFill>
                   <a:srgbClr val="CE9178"/>
                 </a:solidFill>
@@ -8836,7 +9045,7 @@
               <a:t>"POST /turnos"</a:t>
             </a:r>
             <a:r>
-              <a:rPr sz="1500" i="0" b="0">
+              <a:rPr sz="1400" i="0" b="0">
                 <a:solidFill>
                   <a:srgbClr val="D4D4D4"/>
                 </a:solidFill>
@@ -8845,7 +9054,7 @@
               <a:t>, </a:t>
             </a:r>
             <a:r>
-              <a:rPr sz="1500" i="0" b="0">
+              <a:rPr sz="1400" i="0" b="0">
                 <a:solidFill>
                   <a:srgbClr val="CE9178"/>
                 </a:solidFill>
@@ -8854,7 +9063,7 @@
               <a:t>"HTTPS/JSON"</a:t>
             </a:r>
             <a:r>
-              <a:rPr sz="1500" i="0" b="0">
+              <a:rPr sz="1400" i="0" b="0">
                 <a:solidFill>
                   <a:srgbClr val="D4D4D4"/>
                 </a:solidFill>
@@ -8866,11 +9075,11 @@
           <a:p>
             <a:pPr>
               <a:spcAft>
-                <a:spcPts val="321"/>
+                <a:spcPts val="300"/>
               </a:spcAft>
             </a:pPr>
             <a:r>
-              <a:rPr sz="1500" i="0" b="0">
+              <a:rPr sz="1400" i="0" b="0">
                 <a:solidFill>
                   <a:srgbClr val="DCDCAA"/>
                 </a:solidFill>
@@ -8879,7 +9088,7 @@
               <a:t>Rel</a:t>
             </a:r>
             <a:r>
-              <a:rPr sz="1500" i="0" b="0">
+              <a:rPr sz="1400" i="0" b="0">
                 <a:solidFill>
                   <a:srgbClr val="D4D4D4"/>
                 </a:solidFill>
@@ -8888,7 +9097,7 @@
               <a:t>(</a:t>
             </a:r>
             <a:r>
-              <a:rPr sz="1500" i="0" b="0">
+              <a:rPr sz="1400" i="0" b="0">
                 <a:solidFill>
                   <a:srgbClr val="D4D4D4"/>
                 </a:solidFill>
@@ -8897,7 +9106,7 @@
               <a:t>api</a:t>
             </a:r>
             <a:r>
-              <a:rPr sz="1500" i="0" b="0">
+              <a:rPr sz="1400" i="0" b="0">
                 <a:solidFill>
                   <a:srgbClr val="D4D4D4"/>
                 </a:solidFill>
@@ -8906,7 +9115,7 @@
               <a:t>, </a:t>
             </a:r>
             <a:r>
-              <a:rPr sz="1500" i="0" b="0">
+              <a:rPr sz="1400" i="0" b="0">
                 <a:solidFill>
                   <a:srgbClr val="D4D4D4"/>
                 </a:solidFill>
@@ -8915,7 +9124,7 @@
               <a:t>db</a:t>
             </a:r>
             <a:r>
-              <a:rPr sz="1500" i="0" b="0">
+              <a:rPr sz="1400" i="0" b="0">
                 <a:solidFill>
                   <a:srgbClr val="D4D4D4"/>
                 </a:solidFill>
@@ -8924,16 +9133,16 @@
               <a:t>, </a:t>
             </a:r>
             <a:r>
-              <a:rPr sz="1500" i="0" b="0">
+              <a:rPr sz="1400" i="0" b="0">
                 <a:solidFill>
                   <a:srgbClr val="CE9178"/>
                 </a:solidFill>
                 <a:latin typeface="Consolas"/>
               </a:rPr>
-              <a:t>"INSERT / SELECT de turnos"</a:t>
-            </a:r>
-            <a:r>
-              <a:rPr sz="1500" i="0" b="0">
+              <a:t>"INSERT / SELECT"</a:t>
+            </a:r>
+            <a:r>
+              <a:rPr sz="1400" i="0" b="0">
                 <a:solidFill>
                   <a:srgbClr val="D4D4D4"/>
                 </a:solidFill>
@@ -8942,7 +9151,7 @@
               <a:t>, </a:t>
             </a:r>
             <a:r>
-              <a:rPr sz="1500" i="0" b="0">
+              <a:rPr sz="1400" i="0" b="0">
                 <a:solidFill>
                   <a:srgbClr val="CE9178"/>
                 </a:solidFill>
@@ -8951,7 +9160,7 @@
               <a:t>"TCP/SQL"</a:t>
             </a:r>
             <a:r>
-              <a:rPr sz="1500" i="0" b="0">
+              <a:rPr sz="1400" i="0" b="0">
                 <a:solidFill>
                   <a:srgbClr val="D4D4D4"/>
                 </a:solidFill>
@@ -8963,11 +9172,11 @@
           <a:p>
             <a:pPr>
               <a:spcAft>
-                <a:spcPts val="321"/>
+                <a:spcPts val="300"/>
               </a:spcAft>
             </a:pPr>
             <a:r>
-              <a:rPr sz="1500" i="0" b="0">
+              <a:rPr sz="1400" i="0" b="0">
                 <a:solidFill>
                   <a:srgbClr val="DCDCAA"/>
                 </a:solidFill>
@@ -8976,7 +9185,7 @@
               <a:t>Rel</a:t>
             </a:r>
             <a:r>
-              <a:rPr sz="1500" i="0" b="0">
+              <a:rPr sz="1400" i="0" b="0">
                 <a:solidFill>
                   <a:srgbClr val="D4D4D4"/>
                 </a:solidFill>
@@ -8985,7 +9194,7 @@
               <a:t>(</a:t>
             </a:r>
             <a:r>
-              <a:rPr sz="1500" i="0" b="0">
+              <a:rPr sz="1400" i="0" b="0">
                 <a:solidFill>
                   <a:srgbClr val="D4D4D4"/>
                 </a:solidFill>
@@ -8994,7 +9203,7 @@
               <a:t>api</a:t>
             </a:r>
             <a:r>
-              <a:rPr sz="1500" i="0" b="0">
+              <a:rPr sz="1400" i="0" b="0">
                 <a:solidFill>
                   <a:srgbClr val="D4D4D4"/>
                 </a:solidFill>
@@ -9003,7 +9212,7 @@
               <a:t>, </a:t>
             </a:r>
             <a:r>
-              <a:rPr sz="1500" i="0" b="0">
+              <a:rPr sz="1400" i="0" b="0">
                 <a:solidFill>
                   <a:srgbClr val="D4D4D4"/>
                 </a:solidFill>
@@ -9012,7 +9221,7 @@
               <a:t>worker</a:t>
             </a:r>
             <a:r>
-              <a:rPr sz="1500" i="0" b="0">
+              <a:rPr sz="1400" i="0" b="0">
                 <a:solidFill>
                   <a:srgbClr val="D4D4D4"/>
                 </a:solidFill>
@@ -9021,16 +9230,16 @@
               <a:t>, </a:t>
             </a:r>
             <a:r>
-              <a:rPr sz="1500" i="0" b="0">
+              <a:rPr sz="1400" i="0" b="0">
                 <a:solidFill>
                   <a:srgbClr val="CE9178"/>
                 </a:solidFill>
                 <a:latin typeface="Consolas"/>
               </a:rPr>
-              <a:t>"Publica aviso-de-turno"</a:t>
-            </a:r>
-            <a:r>
-              <a:rPr sz="1500" i="0" b="0">
+              <a:t>"Publica aviso"</a:t>
+            </a:r>
+            <a:r>
+              <a:rPr sz="1400" i="0" b="0">
                 <a:solidFill>
                   <a:srgbClr val="D4D4D4"/>
                 </a:solidFill>
@@ -9039,16 +9248,16 @@
               <a:t>, </a:t>
             </a:r>
             <a:r>
-              <a:rPr sz="1500" i="0" b="0">
+              <a:rPr sz="1400" i="0" b="0">
                 <a:solidFill>
                   <a:srgbClr val="CE9178"/>
                 </a:solidFill>
                 <a:latin typeface="Consolas"/>
               </a:rPr>
-              <a:t>"evento/cola (AMQP)"</a:t>
-            </a:r>
-            <a:r>
-              <a:rPr sz="1500" i="0" b="0">
+              <a:t>"evento (AMQP)"</a:t>
+            </a:r>
+            <a:r>
+              <a:rPr sz="1400" i="0" b="0">
                 <a:solidFill>
                   <a:srgbClr val="D4D4D4"/>
                 </a:solidFill>
@@ -9060,11 +9269,11 @@
           <a:p>
             <a:pPr>
               <a:spcAft>
-                <a:spcPts val="321"/>
+                <a:spcPts val="300"/>
               </a:spcAft>
             </a:pPr>
             <a:r>
-              <a:rPr sz="1500" i="0" b="0">
+              <a:rPr sz="1400" i="0" b="0">
                 <a:solidFill>
                   <a:srgbClr val="DCDCAA"/>
                 </a:solidFill>
@@ -9073,7 +9282,7 @@
               <a:t>Rel</a:t>
             </a:r>
             <a:r>
-              <a:rPr sz="1500" i="0" b="0">
+              <a:rPr sz="1400" i="0" b="0">
                 <a:solidFill>
                   <a:srgbClr val="D4D4D4"/>
                 </a:solidFill>
@@ -9082,7 +9291,7 @@
               <a:t>(</a:t>
             </a:r>
             <a:r>
-              <a:rPr sz="1500" i="0" b="0">
+              <a:rPr sz="1400" i="0" b="0">
                 <a:solidFill>
                   <a:srgbClr val="D4D4D4"/>
                 </a:solidFill>
@@ -9091,7 +9300,7 @@
               <a:t>worker</a:t>
             </a:r>
             <a:r>
-              <a:rPr sz="1500" i="0" b="0">
+              <a:rPr sz="1400" i="0" b="0">
                 <a:solidFill>
                   <a:srgbClr val="D4D4D4"/>
                 </a:solidFill>
@@ -9100,7 +9309,7 @@
               <a:t>, </a:t>
             </a:r>
             <a:r>
-              <a:rPr sz="1500" i="0" b="0">
+              <a:rPr sz="1400" i="0" b="0">
                 <a:solidFill>
                   <a:srgbClr val="D4D4D4"/>
                 </a:solidFill>
@@ -9109,7 +9318,7 @@
               <a:t>correo</a:t>
             </a:r>
             <a:r>
-              <a:rPr sz="1500" i="0" b="0">
+              <a:rPr sz="1400" i="0" b="0">
                 <a:solidFill>
                   <a:srgbClr val="D4D4D4"/>
                 </a:solidFill>
@@ -9118,16 +9327,16 @@
               <a:t>, </a:t>
             </a:r>
             <a:r>
-              <a:rPr sz="1500" i="0" b="0">
+              <a:rPr sz="1400" i="0" b="0">
                 <a:solidFill>
                   <a:srgbClr val="CE9178"/>
                 </a:solidFill>
                 <a:latin typeface="Consolas"/>
               </a:rPr>
-              <a:t>"Envia la confirmacion"</a:t>
-            </a:r>
-            <a:r>
-              <a:rPr sz="1500" i="0" b="0">
+              <a:t>"Envia"</a:t>
+            </a:r>
+            <a:r>
+              <a:rPr sz="1400" i="0" b="0">
                 <a:solidFill>
                   <a:srgbClr val="D4D4D4"/>
                 </a:solidFill>
@@ -9136,16 +9345,16 @@
               <a:t>, </a:t>
             </a:r>
             <a:r>
-              <a:rPr sz="1500" i="0" b="0">
+              <a:rPr sz="1400" i="0" b="0">
                 <a:solidFill>
                   <a:srgbClr val="CE9178"/>
                 </a:solidFill>
                 <a:latin typeface="Consolas"/>
               </a:rPr>
-              <a:t>"API REST sobre HTTPS"</a:t>
-            </a:r>
-            <a:r>
-              <a:rPr sz="1500" i="0" b="0">
+              <a:t>"REST/HTTPS"</a:t>
+            </a:r>
+            <a:r>
+              <a:rPr sz="1400" i="0" b="0">
                 <a:solidFill>
                   <a:srgbClr val="D4D4D4"/>
                 </a:solidFill>
@@ -9158,14 +9367,83 @@
       </p:sp>
       <p:sp>
         <p:nvSpPr>
-          <p:cNvPr id="13" name="TextBox 12"/>
+          <p:cNvPr id="13" name="Rounded Rectangle 12"/>
+          <p:cNvSpPr/>
+          <p:nvPr/>
+        </p:nvSpPr>
+        <p:spPr>
+          <a:xfrm>
+            <a:off x="7668579" y="1261872"/>
+            <a:ext cx="4120780" cy="3318569"/>
+          </a:xfrm>
+          <a:prstGeom prst="roundRect">
+            <a:avLst>
+              <a:gd name="adj" fmla="val 4000"/>
+            </a:avLst>
+          </a:prstGeom>
+          <a:solidFill>
+            <a:srgbClr val="E8EEF4"/>
+          </a:solidFill>
+          <a:ln>
+            <a:noFill/>
+          </a:ln>
+        </p:spPr>
+        <p:style>
+          <a:lnRef idx="1">
+            <a:schemeClr val="accent1"/>
+          </a:lnRef>
+          <a:fillRef idx="3">
+            <a:schemeClr val="accent1"/>
+          </a:fillRef>
+          <a:effectRef idx="2">
+            <a:schemeClr val="accent1"/>
+          </a:effectRef>
+          <a:fontRef idx="minor">
+            <a:schemeClr val="lt1"/>
+          </a:fontRef>
+        </p:style>
+        <p:txBody>
+          <a:bodyPr rtlCol="0" anchor="ctr"/>
+          <a:lstStyle/>
+          <a:p>
+            <a:pPr algn="ctr"/>
+          </a:p>
+        </p:txBody>
+      </p:sp>
+      <p:pic>
+        <p:nvPicPr>
+          <p:cNvPr id="14" name="Picture 13" descr="ilus-c4-molde-paso1.png"/>
+          <p:cNvPicPr>
+            <a:picLocks noChangeAspect="1"/>
+          </p:cNvPicPr>
+          <p:nvPr/>
+        </p:nvPicPr>
+        <p:blipFill>
+          <a:blip r:embed="rId2"/>
+          <a:stretch>
+            <a:fillRect/>
+          </a:stretch>
+        </p:blipFill>
+        <p:spPr>
+          <a:xfrm>
+            <a:off x="7723443" y="1316736"/>
+            <a:ext cx="4011052" cy="3208841"/>
+          </a:xfrm>
+          <a:prstGeom prst="rect">
+            <a:avLst/>
+          </a:prstGeom>
+        </p:spPr>
+      </p:pic>
+      <p:sp>
+        <p:nvSpPr>
+          <p:cNvPr id="15" name="TextBox 14"/>
           <p:cNvSpPr txBox="1"/>
           <p:nvPr/>
         </p:nvSpPr>
         <p:spPr>
           <a:xfrm>
-            <a:off x="457200" y="6035040"/>
-            <a:ext cx="11277295" cy="365760"/>
+            <a:off x="7723443" y="4580441"/>
+            <a:ext cx="4011052" cy="320040"/>
           </a:xfrm>
           <a:prstGeom prst="rect">
             <a:avLst/>
@@ -9180,6 +9458,41 @@
           <a:p>
             <a:pPr algn="ctr"/>
             <a:r>
+              <a:rPr sz="1200" b="0" i="1">
+                <a:solidFill>
+                  <a:srgbClr val="666666"/>
+                </a:solidFill>
+                <a:latin typeface="Calibri"/>
+              </a:rPr>
+              <a:t>Lo que dibuja este código</a:t>
+            </a:r>
+          </a:p>
+        </p:txBody>
+      </p:sp>
+      <p:sp>
+        <p:nvSpPr>
+          <p:cNvPr id="16" name="TextBox 15"/>
+          <p:cNvSpPr txBox="1"/>
+          <p:nvPr/>
+        </p:nvSpPr>
+        <p:spPr>
+          <a:xfrm>
+            <a:off x="457200" y="6035040"/>
+            <a:ext cx="11277295" cy="365760"/>
+          </a:xfrm>
+          <a:prstGeom prst="rect">
+            <a:avLst/>
+          </a:prstGeom>
+          <a:noFill/>
+        </p:spPr>
+        <p:txBody>
+          <a:bodyPr wrap="square">
+            <a:spAutoFit/>
+          </a:bodyPr>
+          <a:lstStyle/>
+          <a:p>
+            <a:pPr algn="ctr"/>
+            <a:r>
               <a:rPr sz="1300" b="0" i="1">
                 <a:solidFill>
                   <a:srgbClr val="666666"/>
@@ -9193,7 +9506,7 @@
       </p:sp>
       <p:sp>
         <p:nvSpPr>
-          <p:cNvPr id="14" name="TextBox 13"/>
+          <p:cNvPr id="17" name="TextBox 16"/>
           <p:cNvSpPr txBox="1"/>
           <p:nvPr/>
         </p:nvSpPr>
@@ -18150,7 +18463,7 @@
         <p:spPr>
           <a:xfrm>
             <a:off x="457200" y="1261872"/>
-            <a:ext cx="11277295" cy="4182625"/>
+            <a:ext cx="6991923" cy="2169874"/>
           </a:xfrm>
           <a:prstGeom prst="roundRect">
             <a:avLst>
@@ -18195,7 +18508,7 @@
         <p:spPr>
           <a:xfrm>
             <a:off x="457200" y="1261872"/>
-            <a:ext cx="11277295" cy="365760"/>
+            <a:ext cx="6991923" cy="365760"/>
           </a:xfrm>
           <a:prstGeom prst="rect">
             <a:avLst/>
@@ -18367,7 +18680,7 @@
         <p:spPr>
           <a:xfrm>
             <a:off x="1371600" y="1298448"/>
-            <a:ext cx="10180015" cy="292608"/>
+            <a:ext cx="5894643" cy="292608"/>
           </a:xfrm>
           <a:prstGeom prst="rect">
             <a:avLst/>
@@ -18399,8 +18712,8 @@
         </p:nvSpPr>
         <p:spPr>
           <a:xfrm>
-            <a:off x="1188720" y="1719072"/>
-            <a:ext cx="10271455" cy="3588265"/>
+            <a:off x="685800" y="1719072"/>
+            <a:ext cx="502920" cy="1575514"/>
           </a:xfrm>
           <a:prstGeom prst="rect">
             <a:avLst/>
@@ -18413,13 +18726,116 @@
           </a:bodyPr>
           <a:lstStyle/>
           <a:p>
+            <a:pPr algn="r">
+              <a:spcAft>
+                <a:spcPts val="342"/>
+              </a:spcAft>
+            </a:pPr>
+            <a:r>
+              <a:rPr sz="1600" i="0" b="0">
+                <a:solidFill>
+                  <a:srgbClr val="858585"/>
+                </a:solidFill>
+                <a:latin typeface="Consolas"/>
+              </a:rPr>
+              <a:t>1</a:t>
+            </a:r>
+          </a:p>
+          <a:p>
+            <a:pPr algn="r">
+              <a:spcAft>
+                <a:spcPts val="342"/>
+              </a:spcAft>
+            </a:pPr>
+            <a:r>
+              <a:rPr sz="1600" i="0" b="0">
+                <a:solidFill>
+                  <a:srgbClr val="858585"/>
+                </a:solidFill>
+                <a:latin typeface="Consolas"/>
+              </a:rPr>
+              <a:t>2</a:t>
+            </a:r>
+          </a:p>
+          <a:p>
+            <a:pPr algn="r">
+              <a:spcAft>
+                <a:spcPts val="342"/>
+              </a:spcAft>
+            </a:pPr>
+            <a:r>
+              <a:rPr sz="1600" i="0" b="0">
+                <a:solidFill>
+                  <a:srgbClr val="858585"/>
+                </a:solidFill>
+                <a:latin typeface="Consolas"/>
+              </a:rPr>
+              <a:t>3</a:t>
+            </a:r>
+          </a:p>
+          <a:p>
+            <a:pPr algn="r">
+              <a:spcAft>
+                <a:spcPts val="342"/>
+              </a:spcAft>
+            </a:pPr>
+            <a:r>
+              <a:rPr sz="1600" i="0" b="0">
+                <a:solidFill>
+                  <a:srgbClr val="858585"/>
+                </a:solidFill>
+                <a:latin typeface="Consolas"/>
+              </a:rPr>
+              <a:t>4</a:t>
+            </a:r>
+          </a:p>
+          <a:p>
+            <a:pPr algn="r">
+              <a:spcAft>
+                <a:spcPts val="342"/>
+              </a:spcAft>
+            </a:pPr>
+            <a:r>
+              <a:rPr sz="1600" i="0" b="0">
+                <a:solidFill>
+                  <a:srgbClr val="858585"/>
+                </a:solidFill>
+                <a:latin typeface="Consolas"/>
+              </a:rPr>
+              <a:t>5</a:t>
+            </a:r>
+          </a:p>
+        </p:txBody>
+      </p:sp>
+      <p:sp>
+        <p:nvSpPr>
+          <p:cNvPr id="12" name="TextBox 11"/>
+          <p:cNvSpPr txBox="1"/>
+          <p:nvPr/>
+        </p:nvSpPr>
+        <p:spPr>
+          <a:xfrm>
+            <a:off x="1188720" y="1719072"/>
+            <a:ext cx="5986083" cy="1575514"/>
+          </a:xfrm>
+          <a:prstGeom prst="rect">
+            <a:avLst/>
+          </a:prstGeom>
+          <a:noFill/>
+        </p:spPr>
+        <p:txBody>
+          <a:bodyPr wrap="square">
+            <a:spAutoFit/>
+          </a:bodyPr>
+          <a:lstStyle/>
+          <a:p>
             <a:pPr>
               <a:spcAft>
-                <a:spcPts val="428"/>
+                <a:spcPts val="342"/>
               </a:spcAft>
             </a:pPr>
             <a:r>
-              <a:rPr sz="2000" i="0" b="0">
+              <a:rPr sz="1600" i="0" b="0">
                 <a:solidFill>
                   <a:srgbClr val="D4D4D4"/>
                 </a:solidFill>
@@ -18431,11 +18847,11 @@
           <a:p>
             <a:pPr>
               <a:spcAft>
-                <a:spcPts val="428"/>
+                <a:spcPts val="342"/>
               </a:spcAft>
             </a:pPr>
             <a:r>
-              <a:rPr sz="2000" i="0" b="0">
+              <a:rPr sz="1600" i="0" b="0">
                 <a:solidFill>
                   <a:srgbClr val="D4D4D4"/>
                 </a:solidFill>
@@ -18444,7 +18860,7 @@
               <a:t>title</a:t>
             </a:r>
             <a:r>
-              <a:rPr sz="2000" i="0" b="0">
+              <a:rPr sz="1600" i="0" b="0">
                 <a:solidFill>
                   <a:srgbClr val="D4D4D4"/>
                 </a:solidFill>
@@ -18453,7 +18869,7 @@
               <a:t> </a:t>
             </a:r>
             <a:r>
-              <a:rPr sz="2000" i="0" b="0">
+              <a:rPr sz="1600" i="0" b="0">
                 <a:solidFill>
                   <a:srgbClr val="D4D4D4"/>
                 </a:solidFill>
@@ -18462,7 +18878,7 @@
               <a:t>Tres</a:t>
             </a:r>
             <a:r>
-              <a:rPr sz="2000" i="0" b="0">
+              <a:rPr sz="1600" i="0" b="0">
                 <a:solidFill>
                   <a:srgbClr val="D4D4D4"/>
                 </a:solidFill>
@@ -18471,7 +18887,7 @@
               <a:t> </a:t>
             </a:r>
             <a:r>
-              <a:rPr sz="2000" i="0" b="0">
+              <a:rPr sz="1600" i="0" b="0">
                 <a:solidFill>
                   <a:srgbClr val="D4D4D4"/>
                 </a:solidFill>
@@ -18480,7 +18896,7 @@
               <a:t>reglas</a:t>
             </a:r>
             <a:r>
-              <a:rPr sz="2000" i="0" b="0">
+              <a:rPr sz="1600" i="0" b="0">
                 <a:solidFill>
                   <a:srgbClr val="D4D4D4"/>
                 </a:solidFill>
@@ -18489,16 +18905,16 @@
               <a:t> </a:t>
             </a:r>
             <a:r>
-              <a:rPr sz="2000" i="0" b="0">
+              <a:rPr sz="1600" i="0" b="0">
                 <a:solidFill>
                   <a:srgbClr val="D4D4D4"/>
                 </a:solidFill>
                 <a:latin typeface="Consolas"/>
               </a:rPr>
-              <a:t>que</a:t>
-            </a:r>
-            <a:r>
-              <a:rPr sz="2000" i="0" b="0">
+              <a:t>del</a:t>
+            </a:r>
+            <a:r>
+              <a:rPr sz="1600" i="0" b="0">
                 <a:solidFill>
                   <a:srgbClr val="D4D4D4"/>
                 </a:solidFill>
@@ -18507,16 +18923,16 @@
               <a:t> </a:t>
             </a:r>
             <a:r>
-              <a:rPr sz="2000" i="0" b="0">
+              <a:rPr sz="1600" i="0" b="0">
                 <a:solidFill>
                   <a:srgbClr val="D4D4D4"/>
                 </a:solidFill>
                 <a:latin typeface="Consolas"/>
               </a:rPr>
-              <a:t>el</a:t>
-            </a:r>
-            <a:r>
-              <a:rPr sz="2000" i="0" b="0">
+              <a:t>nivel</a:t>
+            </a:r>
+            <a:r>
+              <a:rPr sz="1600" i="0" b="0">
                 <a:solidFill>
                   <a:srgbClr val="D4D4D4"/>
                 </a:solidFill>
@@ -18525,120 +18941,111 @@
               <a:t> </a:t>
             </a:r>
             <a:r>
-              <a:rPr sz="2000" i="0" b="0">
+              <a:rPr sz="1600" i="0" b="0">
                 <a:solidFill>
                   <a:srgbClr val="D4D4D4"/>
                 </a:solidFill>
                 <a:latin typeface="Consolas"/>
               </a:rPr>
-              <a:t>visor</a:t>
-            </a:r>
-            <a:r>
-              <a:rPr sz="2000" i="0" b="0">
-                <a:solidFill>
-                  <a:srgbClr val="D4D4D4"/>
-                </a:solidFill>
-                <a:latin typeface="Consolas"/>
-              </a:rPr>
-              <a:t> </a:t>
-            </a:r>
-            <a:r>
-              <a:rPr sz="2000" i="0" b="0">
-                <a:solidFill>
-                  <a:srgbClr val="D4D4D4"/>
-                </a:solidFill>
-                <a:latin typeface="Consolas"/>
-              </a:rPr>
-              <a:t>no</a:t>
-            </a:r>
-            <a:r>
-              <a:rPr sz="2000" i="0" b="0">
-                <a:solidFill>
-                  <a:srgbClr val="D4D4D4"/>
-                </a:solidFill>
-                <a:latin typeface="Consolas"/>
-              </a:rPr>
-              <a:t> </a:t>
-            </a:r>
-            <a:r>
-              <a:rPr sz="2000" i="0" b="0">
-                <a:solidFill>
-                  <a:srgbClr val="D4D4D4"/>
-                </a:solidFill>
-                <a:latin typeface="Consolas"/>
-              </a:rPr>
-              <a:t>revisa</a:t>
-            </a:r>
-            <a:r>
-              <a:rPr sz="2000" i="0" b="0">
-                <a:solidFill>
-                  <a:srgbClr val="D4D4D4"/>
-                </a:solidFill>
-                <a:latin typeface="Consolas"/>
-              </a:rPr>
-              <a:t> </a:t>
-            </a:r>
-            <a:r>
-              <a:rPr sz="2000" i="0" b="0">
-                <a:solidFill>
-                  <a:srgbClr val="D4D4D4"/>
-                </a:solidFill>
-                <a:latin typeface="Consolas"/>
-              </a:rPr>
-              <a:t>por</a:t>
-            </a:r>
-            <a:r>
-              <a:rPr sz="2000" i="0" b="0">
-                <a:solidFill>
-                  <a:srgbClr val="D4D4D4"/>
-                </a:solidFill>
-                <a:latin typeface="Consolas"/>
-              </a:rPr>
-              <a:t> </a:t>
-            </a:r>
-            <a:r>
-              <a:rPr sz="2000" i="0" b="0">
-                <a:solidFill>
-                  <a:srgbClr val="D4D4D4"/>
-                </a:solidFill>
-                <a:latin typeface="Consolas"/>
-              </a:rPr>
-              <a:t>ti</a:t>
+              <a:t>Container</a:t>
             </a:r>
           </a:p>
           <a:p>
             <a:pPr>
               <a:spcAft>
-                <a:spcPts val="428"/>
+                <a:spcPts val="342"/>
               </a:spcAft>
             </a:pPr>
             <a:r>
-              <a:rPr sz="2000" i="1" b="0">
-                <a:solidFill>
-                  <a:srgbClr val="6A9955"/>
+              <a:rPr sz="1600" i="0" b="0">
+                <a:solidFill>
+                  <a:srgbClr val="DCDCAA"/>
                 </a:solidFill>
                 <a:latin typeface="Consolas"/>
               </a:rPr>
-              <a:t>%% 1. Cada contenedor con TECNOLOGIA.  Mal: Container(api, "API")</a:t>
+              <a:t>Container</a:t>
+            </a:r>
+            <a:r>
+              <a:rPr sz="1600" i="0" b="0">
+                <a:solidFill>
+                  <a:srgbClr val="D4D4D4"/>
+                </a:solidFill>
+                <a:latin typeface="Consolas"/>
+              </a:rPr>
+              <a:t>(</a:t>
+            </a:r>
+            <a:r>
+              <a:rPr sz="1600" i="0" b="0">
+                <a:solidFill>
+                  <a:srgbClr val="D4D4D4"/>
+                </a:solidFill>
+                <a:latin typeface="Consolas"/>
+              </a:rPr>
+              <a:t>api</a:t>
+            </a:r>
+            <a:r>
+              <a:rPr sz="1600" i="0" b="0">
+                <a:solidFill>
+                  <a:srgbClr val="D4D4D4"/>
+                </a:solidFill>
+                <a:latin typeface="Consolas"/>
+              </a:rPr>
+              <a:t>, </a:t>
+            </a:r>
+            <a:r>
+              <a:rPr sz="1600" i="0" b="0">
+                <a:solidFill>
+                  <a:srgbClr val="CE9178"/>
+                </a:solidFill>
+                <a:latin typeface="Consolas"/>
+              </a:rPr>
+              <a:t>"API de turnos"</a:t>
+            </a:r>
+            <a:r>
+              <a:rPr sz="1600" i="0" b="0">
+                <a:solidFill>
+                  <a:srgbClr val="D4D4D4"/>
+                </a:solidFill>
+                <a:latin typeface="Consolas"/>
+              </a:rPr>
+              <a:t>, </a:t>
+            </a:r>
+            <a:r>
+              <a:rPr sz="1600" i="0" b="0">
+                <a:solidFill>
+                  <a:srgbClr val="CE9178"/>
+                </a:solidFill>
+                <a:latin typeface="Consolas"/>
+              </a:rPr>
+              <a:t>"Node.js"</a:t>
+            </a:r>
+            <a:r>
+              <a:rPr sz="1600" i="0" b="0">
+                <a:solidFill>
+                  <a:srgbClr val="D4D4D4"/>
+                </a:solidFill>
+                <a:latin typeface="Consolas"/>
+              </a:rPr>
+              <a:t>)</a:t>
             </a:r>
           </a:p>
           <a:p>
             <a:pPr>
               <a:spcAft>
-                <a:spcPts val="428"/>
+                <a:spcPts val="342"/>
               </a:spcAft>
             </a:pPr>
             <a:r>
-              <a:rPr sz="2000" i="0" b="0">
+              <a:rPr sz="1600" i="0" b="0">
                 <a:solidFill>
                   <a:srgbClr val="DCDCAA"/>
                 </a:solidFill>
                 <a:latin typeface="Consolas"/>
               </a:rPr>
-              <a:t>Container</a:t>
-            </a:r>
-            <a:r>
-              <a:rPr sz="2000" i="0" b="0">
+              <a:t>ContainerDb</a:t>
+            </a:r>
+            <a:r>
+              <a:rPr sz="1600" i="0" b="0">
                 <a:solidFill>
                   <a:srgbClr val="D4D4D4"/>
                 </a:solidFill>
@@ -18647,16 +19054,16 @@
               <a:t>(</a:t>
             </a:r>
             <a:r>
-              <a:rPr sz="2000" i="0" b="0">
+              <a:rPr sz="1600" i="0" b="0">
                 <a:solidFill>
                   <a:srgbClr val="D4D4D4"/>
                 </a:solidFill>
                 <a:latin typeface="Consolas"/>
               </a:rPr>
-              <a:t>api</a:t>
-            </a:r>
-            <a:r>
-              <a:rPr sz="2000" i="0" b="0">
+              <a:t>db</a:t>
+            </a:r>
+            <a:r>
+              <a:rPr sz="1600" i="0" b="0">
                 <a:solidFill>
                   <a:srgbClr val="D4D4D4"/>
                 </a:solidFill>
@@ -18665,16 +19072,16 @@
               <a:t>, </a:t>
             </a:r>
             <a:r>
-              <a:rPr sz="2000" i="0" b="0">
+              <a:rPr sz="1600" i="0" b="0">
                 <a:solidFill>
                   <a:srgbClr val="CE9178"/>
                 </a:solidFill>
                 <a:latin typeface="Consolas"/>
               </a:rPr>
-              <a:t>"API de turnos"</a:t>
-            </a:r>
-            <a:r>
-              <a:rPr sz="2000" i="0" b="0">
+              <a:t>"Base de turnos"</a:t>
+            </a:r>
+            <a:r>
+              <a:rPr sz="1600" i="0" b="0">
                 <a:solidFill>
                   <a:srgbClr val="D4D4D4"/>
                 </a:solidFill>
@@ -18683,34 +19090,16 @@
               <a:t>, </a:t>
             </a:r>
             <a:r>
-              <a:rPr sz="2000" i="0" b="0">
+              <a:rPr sz="1600" i="0" b="0">
                 <a:solidFill>
                   <a:srgbClr val="CE9178"/>
                 </a:solidFill>
                 <a:latin typeface="Consolas"/>
               </a:rPr>
-              <a:t>"Node.js"</a:t>
-            </a:r>
-            <a:r>
-              <a:rPr sz="2000" i="0" b="0">
-                <a:solidFill>
-                  <a:srgbClr val="D4D4D4"/>
-                </a:solidFill>
-                <a:latin typeface="Consolas"/>
-              </a:rPr>
-              <a:t>, </a:t>
-            </a:r>
-            <a:r>
-              <a:rPr sz="2000" i="0" b="0">
-                <a:solidFill>
-                  <a:srgbClr val="CE9178"/>
-                </a:solidFill>
-                <a:latin typeface="Consolas"/>
-              </a:rPr>
-              <a:t>"Valida la franja y registra el turno"</a:t>
-            </a:r>
-            <a:r>
-              <a:rPr sz="2000" i="0" b="0">
+              <a:t>"PostgreSQL"</a:t>
+            </a:r>
+            <a:r>
+              <a:rPr sz="1600" i="0" b="0">
                 <a:solidFill>
                   <a:srgbClr val="D4D4D4"/>
                 </a:solidFill>
@@ -18722,54 +19111,56 @@
           <a:p>
             <a:pPr>
               <a:spcAft>
-                <a:spcPts val="428"/>
+                <a:spcPts val="342"/>
               </a:spcAft>
             </a:pPr>
             <a:r>
-              <a:rPr sz="2000" i="1" b="0">
-                <a:solidFill>
-                  <a:srgbClr val="6A9955"/>
+              <a:rPr sz="1600" i="0" b="0">
+                <a:solidFill>
+                  <a:srgbClr val="DCDCAA"/>
                 </a:solidFill>
                 <a:latin typeface="Consolas"/>
               </a:rPr>
-              <a:t>%% 2. Lo que guarda datos es ContainerDb, no un Container mas</a:t>
-            </a:r>
-          </a:p>
-          <a:p>
-            <a:pPr>
-              <a:spcAft>
-                <a:spcPts val="428"/>
-              </a:spcAft>
-            </a:pPr>
-            <a:r>
-              <a:rPr sz="2000" i="0" b="0">
-                <a:solidFill>
-                  <a:srgbClr val="DCDCAA"/>
+              <a:t>Rel</a:t>
+            </a:r>
+            <a:r>
+              <a:rPr sz="1600" i="0" b="0">
+                <a:solidFill>
+                  <a:srgbClr val="D4D4D4"/>
                 </a:solidFill>
                 <a:latin typeface="Consolas"/>
               </a:rPr>
-              <a:t>ContainerDb</a:t>
-            </a:r>
-            <a:r>
-              <a:rPr sz="2000" i="0" b="0">
+              <a:t>(</a:t>
+            </a:r>
+            <a:r>
+              <a:rPr sz="1600" i="0" b="0">
                 <a:solidFill>
                   <a:srgbClr val="D4D4D4"/>
                 </a:solidFill>
                 <a:latin typeface="Consolas"/>
               </a:rPr>
-              <a:t>(</a:t>
-            </a:r>
-            <a:r>
-              <a:rPr sz="2000" i="0" b="0">
+              <a:t>api</a:t>
+            </a:r>
+            <a:r>
+              <a:rPr sz="1600" i="0" b="0">
                 <a:solidFill>
                   <a:srgbClr val="D4D4D4"/>
                 </a:solidFill>
                 <a:latin typeface="Consolas"/>
               </a:rPr>
+              <a:t>, </a:t>
+            </a:r>
+            <a:r>
+              <a:rPr sz="1600" i="0" b="0">
+                <a:solidFill>
+                  <a:srgbClr val="D4D4D4"/>
+                </a:solidFill>
+                <a:latin typeface="Consolas"/>
+              </a:rPr>
               <a:t>db</a:t>
             </a:r>
             <a:r>
-              <a:rPr sz="2000" i="0" b="0">
+              <a:rPr sz="1600" i="0" b="0">
                 <a:solidFill>
                   <a:srgbClr val="D4D4D4"/>
                 </a:solidFill>
@@ -18778,16 +19169,16 @@
               <a:t>, </a:t>
             </a:r>
             <a:r>
-              <a:rPr sz="2000" i="0" b="0">
+              <a:rPr sz="1600" i="0" b="0">
                 <a:solidFill>
                   <a:srgbClr val="CE9178"/>
                 </a:solidFill>
                 <a:latin typeface="Consolas"/>
               </a:rPr>
-              <a:t>"Base de turnos"</a:t>
-            </a:r>
-            <a:r>
-              <a:rPr sz="2000" i="0" b="0">
+              <a:t>"INSERT y SELECT"</a:t>
+            </a:r>
+            <a:r>
+              <a:rPr sz="1600" i="0" b="0">
                 <a:solidFill>
                   <a:srgbClr val="D4D4D4"/>
                 </a:solidFill>
@@ -18796,176 +19187,133 @@
               <a:t>, </a:t>
             </a:r>
             <a:r>
-              <a:rPr sz="2000" i="0" b="0">
+              <a:rPr sz="1600" i="0" b="0">
                 <a:solidFill>
                   <a:srgbClr val="CE9178"/>
                 </a:solidFill>
                 <a:latin typeface="Consolas"/>
               </a:rPr>
-              <a:t>"PostgreSQL"</a:t>
-            </a:r>
-            <a:r>
-              <a:rPr sz="2000" i="0" b="0">
+              <a:t>"TCP/SQL"</a:t>
+            </a:r>
+            <a:r>
+              <a:rPr sz="1600" i="0" b="0">
                 <a:solidFill>
                   <a:srgbClr val="D4D4D4"/>
                 </a:solidFill>
                 <a:latin typeface="Consolas"/>
               </a:rPr>
-              <a:t>, </a:t>
-            </a:r>
-            <a:r>
-              <a:rPr sz="2000" i="0" b="0">
-                <a:solidFill>
-                  <a:srgbClr val="CE9178"/>
-                </a:solidFill>
-                <a:latin typeface="Consolas"/>
-              </a:rPr>
-              <a:t>"Turnos y horarios"</a:t>
-            </a:r>
-            <a:r>
-              <a:rPr sz="2000" i="0" b="0">
-                <a:solidFill>
-                  <a:srgbClr val="D4D4D4"/>
-                </a:solidFill>
-                <a:latin typeface="Consolas"/>
-              </a:rPr>
               <a:t>)</a:t>
             </a:r>
           </a:p>
-          <a:p>
-            <a:pPr>
-              <a:spcAft>
-                <a:spcPts val="428"/>
-              </a:spcAft>
-            </a:pPr>
-            <a:r>
-              <a:rPr sz="2000" i="1" b="0">
-                <a:solidFill>
-                  <a:srgbClr val="6A9955"/>
-                </a:solidFill>
-                <a:latin typeface="Consolas"/>
-              </a:rPr>
-              <a:t>%% 3. Cada Rel con verbo, protocolo Y formato.  Mal: Rel(api, db, "usa")</a:t>
-            </a:r>
-          </a:p>
-          <a:p>
-            <a:pPr>
-              <a:spcAft>
-                <a:spcPts val="428"/>
-              </a:spcAft>
-            </a:pPr>
-            <a:r>
-              <a:rPr sz="2000" i="0" b="0">
-                <a:solidFill>
-                  <a:srgbClr val="DCDCAA"/>
-                </a:solidFill>
-                <a:latin typeface="Consolas"/>
-              </a:rPr>
-              <a:t>Rel</a:t>
-            </a:r>
-            <a:r>
-              <a:rPr sz="2000" i="0" b="0">
-                <a:solidFill>
-                  <a:srgbClr val="D4D4D4"/>
-                </a:solidFill>
-                <a:latin typeface="Consolas"/>
-              </a:rPr>
-              <a:t>(</a:t>
-            </a:r>
-            <a:r>
-              <a:rPr sz="2000" i="0" b="0">
-                <a:solidFill>
-                  <a:srgbClr val="D4D4D4"/>
-                </a:solidFill>
-                <a:latin typeface="Consolas"/>
-              </a:rPr>
-              <a:t>api</a:t>
-            </a:r>
-            <a:r>
-              <a:rPr sz="2000" i="0" b="0">
-                <a:solidFill>
-                  <a:srgbClr val="D4D4D4"/>
-                </a:solidFill>
-                <a:latin typeface="Consolas"/>
-              </a:rPr>
-              <a:t>, </a:t>
-            </a:r>
-            <a:r>
-              <a:rPr sz="2000" i="0" b="0">
-                <a:solidFill>
-                  <a:srgbClr val="D4D4D4"/>
-                </a:solidFill>
-                <a:latin typeface="Consolas"/>
-              </a:rPr>
-              <a:t>db</a:t>
-            </a:r>
-            <a:r>
-              <a:rPr sz="2000" i="0" b="0">
-                <a:solidFill>
-                  <a:srgbClr val="D4D4D4"/>
-                </a:solidFill>
-                <a:latin typeface="Consolas"/>
-              </a:rPr>
-              <a:t>, </a:t>
-            </a:r>
-            <a:r>
-              <a:rPr sz="2000" i="0" b="0">
-                <a:solidFill>
-                  <a:srgbClr val="CE9178"/>
-                </a:solidFill>
-                <a:latin typeface="Consolas"/>
-              </a:rPr>
-              <a:t>"INSERT y SELECT de turnos"</a:t>
-            </a:r>
-            <a:r>
-              <a:rPr sz="2000" i="0" b="0">
-                <a:solidFill>
-                  <a:srgbClr val="D4D4D4"/>
-                </a:solidFill>
-                <a:latin typeface="Consolas"/>
-              </a:rPr>
-              <a:t>, </a:t>
-            </a:r>
-            <a:r>
-              <a:rPr sz="2000" i="0" b="0">
-                <a:solidFill>
-                  <a:srgbClr val="CE9178"/>
-                </a:solidFill>
-                <a:latin typeface="Consolas"/>
-              </a:rPr>
-              <a:t>"TCP/SQL"</a:t>
-            </a:r>
-            <a:r>
-              <a:rPr sz="2000" i="0" b="0">
-                <a:solidFill>
-                  <a:srgbClr val="D4D4D4"/>
-                </a:solidFill>
-                <a:latin typeface="Consolas"/>
-              </a:rPr>
-              <a:t>)</a:t>
-            </a:r>
-          </a:p>
-          <a:p>
-            <a:pPr>
-              <a:spcAft>
-                <a:spcPts val="428"/>
-              </a:spcAft>
-            </a:pPr>
-            <a:r>
-              <a:rPr sz="2000" i="1" b="0">
-                <a:solidFill>
-                  <a:srgbClr val="6A9955"/>
-                </a:solidFill>
-                <a:latin typeface="Consolas"/>
-              </a:rPr>
-              <a:t>%% Y los nombres se repiten IGUALES en el Despliegue y en el Component.</a:t>
-            </a:r>
-          </a:p>
-        </p:txBody>
-      </p:sp>
-      <p:sp>
-        <p:nvSpPr>
-          <p:cNvPr id="12" name="TextBox 11"/>
+        </p:txBody>
+      </p:sp>
+      <p:sp>
+        <p:nvSpPr>
+          <p:cNvPr id="13" name="Rounded Rectangle 12"/>
+          <p:cNvSpPr/>
+          <p:nvPr/>
+        </p:nvSpPr>
+        <p:spPr>
+          <a:xfrm>
+            <a:off x="7668579" y="1261872"/>
+            <a:ext cx="4120780" cy="3318569"/>
+          </a:xfrm>
+          <a:prstGeom prst="roundRect">
+            <a:avLst>
+              <a:gd name="adj" fmla="val 4000"/>
+            </a:avLst>
+          </a:prstGeom>
+          <a:solidFill>
+            <a:srgbClr val="E8EEF4"/>
+          </a:solidFill>
+          <a:ln>
+            <a:noFill/>
+          </a:ln>
+        </p:spPr>
+        <p:style>
+          <a:lnRef idx="1">
+            <a:schemeClr val="accent1"/>
+          </a:lnRef>
+          <a:fillRef idx="3">
+            <a:schemeClr val="accent1"/>
+          </a:fillRef>
+          <a:effectRef idx="2">
+            <a:schemeClr val="accent1"/>
+          </a:effectRef>
+          <a:fontRef idx="minor">
+            <a:schemeClr val="lt1"/>
+          </a:fontRef>
+        </p:style>
+        <p:txBody>
+          <a:bodyPr rtlCol="0" anchor="ctr"/>
+          <a:lstStyle/>
+          <a:p>
+            <a:pPr algn="ctr"/>
+          </a:p>
+        </p:txBody>
+      </p:sp>
+      <p:pic>
+        <p:nvPicPr>
+          <p:cNvPr id="14" name="Picture 13" descr="ilus-c4-reglas-paso1.png"/>
+          <p:cNvPicPr>
+            <a:picLocks noChangeAspect="1"/>
+          </p:cNvPicPr>
+          <p:nvPr/>
+        </p:nvPicPr>
+        <p:blipFill>
+          <a:blip r:embed="rId2"/>
+          <a:stretch>
+            <a:fillRect/>
+          </a:stretch>
+        </p:blipFill>
+        <p:spPr>
+          <a:xfrm>
+            <a:off x="7723443" y="1316736"/>
+            <a:ext cx="4011052" cy="3208841"/>
+          </a:xfrm>
+          <a:prstGeom prst="rect">
+            <a:avLst/>
+          </a:prstGeom>
+        </p:spPr>
+      </p:pic>
+      <p:sp>
+        <p:nvSpPr>
+          <p:cNvPr id="15" name="TextBox 14"/>
+          <p:cNvSpPr txBox="1"/>
+          <p:nvPr/>
+        </p:nvSpPr>
+        <p:spPr>
+          <a:xfrm>
+            <a:off x="7723443" y="4580441"/>
+            <a:ext cx="4011052" cy="320040"/>
+          </a:xfrm>
+          <a:prstGeom prst="rect">
+            <a:avLst/>
+          </a:prstGeom>
+          <a:noFill/>
+        </p:spPr>
+        <p:txBody>
+          <a:bodyPr wrap="square">
+            <a:spAutoFit/>
+          </a:bodyPr>
+          <a:lstStyle/>
+          <a:p>
+            <a:pPr algn="ctr"/>
+            <a:r>
+              <a:rPr sz="1200" b="0" i="1">
+                <a:solidFill>
+                  <a:srgbClr val="666666"/>
+                </a:solidFill>
+                <a:latin typeface="Calibri"/>
+              </a:rPr>
+              <a:t>Lo que dibuja este código</a:t>
+            </a:r>
+          </a:p>
+        </p:txBody>
+      </p:sp>
+      <p:sp>
+        <p:nvSpPr>
+          <p:cNvPr id="16" name="TextBox 15"/>
           <p:cNvSpPr txBox="1"/>
           <p:nvPr/>
         </p:nvSpPr>

</xml_diff>